<commit_message>
Implement Random LSB encode/decode and UI
Add Random LSB steganography support: RandomLsbEncoder, RandomLsbDecoder, and RandomPositionGenerator. Encoder writes a 32-bit length header and message bits into randomized RGB LSB positions (password-derived SHA-256 seed), using a deep copy of the source image; decoder regenerates positions, validates capacity via CapacityCalculator, and reconstructs the embedded message with MessageConverter utilities. Integrate random embed/extract options into SteganographyApp, include a sample stego image, update .gitignore (out, *.class, .idea) and add IntelliJ module file.
</commit_message>
<xml_diff>
--- a/Steganography/Steganografija i LSB skrivanje poruka u slikama.pptx
+++ b/Steganography/Steganografija i LSB skrivanje poruka u slikama.pptx
@@ -5,36 +5,38 @@
     <p:sldMasterId id="2147483648" r:id="rId1"/>
   </p:sldMasterIdLst>
   <p:notesMasterIdLst>
-    <p:notesMasterId r:id="rId27"/>
+    <p:notesMasterId r:id="rId29"/>
   </p:notesMasterIdLst>
   <p:handoutMasterIdLst>
-    <p:handoutMasterId r:id="rId28"/>
+    <p:handoutMasterId r:id="rId30"/>
   </p:handoutMasterIdLst>
   <p:sldIdLst>
     <p:sldId id="256" r:id="rId3"/>
     <p:sldId id="264" r:id="rId4"/>
     <p:sldId id="259" r:id="rId5"/>
     <p:sldId id="266" r:id="rId6"/>
-    <p:sldId id="276" r:id="rId7"/>
-    <p:sldId id="279" r:id="rId8"/>
-    <p:sldId id="280" r:id="rId9"/>
-    <p:sldId id="281" r:id="rId10"/>
-    <p:sldId id="282" r:id="rId11"/>
-    <p:sldId id="272" r:id="rId12"/>
-    <p:sldId id="263" r:id="rId13"/>
-    <p:sldId id="262" r:id="rId14"/>
-    <p:sldId id="261" r:id="rId15"/>
-    <p:sldId id="258" r:id="rId16"/>
-    <p:sldId id="265" r:id="rId17"/>
-    <p:sldId id="267" r:id="rId18"/>
-    <p:sldId id="260" r:id="rId19"/>
-    <p:sldId id="273" r:id="rId20"/>
-    <p:sldId id="268" r:id="rId21"/>
-    <p:sldId id="269" r:id="rId22"/>
-    <p:sldId id="270" r:id="rId23"/>
-    <p:sldId id="271" r:id="rId24"/>
-    <p:sldId id="275" r:id="rId25"/>
-    <p:sldId id="274" r:id="rId26"/>
+    <p:sldId id="283" r:id="rId7"/>
+    <p:sldId id="284" r:id="rId8"/>
+    <p:sldId id="276" r:id="rId9"/>
+    <p:sldId id="279" r:id="rId10"/>
+    <p:sldId id="280" r:id="rId11"/>
+    <p:sldId id="281" r:id="rId12"/>
+    <p:sldId id="282" r:id="rId13"/>
+    <p:sldId id="272" r:id="rId14"/>
+    <p:sldId id="263" r:id="rId15"/>
+    <p:sldId id="262" r:id="rId16"/>
+    <p:sldId id="261" r:id="rId17"/>
+    <p:sldId id="258" r:id="rId18"/>
+    <p:sldId id="265" r:id="rId19"/>
+    <p:sldId id="267" r:id="rId20"/>
+    <p:sldId id="260" r:id="rId21"/>
+    <p:sldId id="273" r:id="rId22"/>
+    <p:sldId id="268" r:id="rId23"/>
+    <p:sldId id="269" r:id="rId24"/>
+    <p:sldId id="270" r:id="rId25"/>
+    <p:sldId id="271" r:id="rId26"/>
+    <p:sldId id="275" r:id="rId27"/>
+    <p:sldId id="274" r:id="rId28"/>
   </p:sldIdLst>
   <p:sldSz cx="12192000" cy="6858000"/>
   <p:notesSz cx="6858000" cy="9144000"/>
@@ -4190,6 +4192,540 @@
       <p:grpSpPr/>
       <p:sp>
         <p:nvSpPr>
+          <p:cNvPr id="2" name="Title 1"/>
+          <p:cNvSpPr>
+            <a:spLocks noGrp="1"/>
+          </p:cNvSpPr>
+          <p:nvPr>
+            <p:ph type="title"/>
+          </p:nvPr>
+        </p:nvSpPr>
+        <p:spPr/>
+        <p:txBody>
+          <a:bodyPr/>
+          <a:p>
+            <a:pPr algn="ctr"/>
+            <a:r>
+              <a:rPr lang="en-US" altLang="en-US"/>
+              <a:t>OutGuess (v0.1)</a:t>
+            </a:r>
+            <a:endParaRPr lang="en-US" altLang="en-US"/>
+          </a:p>
+        </p:txBody>
+      </p:sp>
+      <p:sp>
+        <p:nvSpPr>
+          <p:cNvPr id="3" name="Text Box 2"/>
+          <p:cNvSpPr txBox="1"/>
+          <p:nvPr/>
+        </p:nvSpPr>
+        <p:spPr>
+          <a:xfrm>
+            <a:off x="2176145" y="2428240"/>
+            <a:ext cx="7840345" cy="2553335"/>
+          </a:xfrm>
+          <a:prstGeom prst="rect">
+            <a:avLst/>
+          </a:prstGeom>
+          <a:noFill/>
+        </p:spPr>
+        <p:txBody>
+          <a:bodyPr wrap="square" rtlCol="0">
+            <a:spAutoFit/>
+          </a:bodyPr>
+          <a:p>
+            <a:pPr marL="285750" indent="-285750">
+              <a:buFont typeface="Wingdings" panose="05000000000000000000" charset="0"/>
+              <a:buChar char="v"/>
+            </a:pPr>
+            <a:r>
+              <a:rPr lang="en-US" altLang="en-US" sz="2000" b="1">
+                <a:solidFill>
+                  <a:schemeClr val="bg1"/>
+                </a:solidFill>
+              </a:rPr>
+              <a:t>Ideja</a:t>
+            </a:r>
+            <a:endParaRPr lang="en-US" altLang="en-US" sz="2000">
+              <a:solidFill>
+                <a:schemeClr val="bg1"/>
+              </a:solidFill>
+            </a:endParaRPr>
+          </a:p>
+          <a:p>
+            <a:pPr marL="285750" indent="-285750">
+              <a:buFont typeface="Wingdings" panose="05000000000000000000" charset="0"/>
+              <a:buChar char="v"/>
+            </a:pPr>
+            <a:endParaRPr lang="en-US" altLang="en-US" sz="2000">
+              <a:solidFill>
+                <a:schemeClr val="bg1"/>
+              </a:solidFill>
+            </a:endParaRPr>
+          </a:p>
+          <a:p>
+            <a:pPr marL="285750" indent="-285750">
+              <a:buFont typeface="Wingdings" panose="05000000000000000000" charset="0"/>
+              <a:buChar char="v"/>
+            </a:pPr>
+            <a:r>
+              <a:rPr lang="en-US" altLang="en-US" sz="2000" b="1">
+                <a:solidFill>
+                  <a:schemeClr val="bg1"/>
+                </a:solidFill>
+              </a:rPr>
+              <a:t>Za</a:t>
+            </a:r>
+            <a:r>
+              <a:rPr lang="en-US" altLang="en-US" sz="2000" b="1">
+                <a:solidFill>
+                  <a:schemeClr val="bg1"/>
+                </a:solidFill>
+              </a:rPr>
+              <a:t>š</a:t>
+            </a:r>
+            <a:r>
+              <a:rPr lang="en-US" altLang="en-US" sz="2000" b="1">
+                <a:solidFill>
+                  <a:schemeClr val="bg1"/>
+                </a:solidFill>
+              </a:rPr>
+              <a:t>to je bolji od obi</a:t>
+            </a:r>
+            <a:r>
+              <a:rPr lang="en-US" altLang="en-US" sz="2000" b="1">
+                <a:solidFill>
+                  <a:schemeClr val="bg1"/>
+                </a:solidFill>
+              </a:rPr>
+              <a:t>č</a:t>
+            </a:r>
+            <a:r>
+              <a:rPr lang="en-US" altLang="en-US" sz="2000" b="1">
+                <a:solidFill>
+                  <a:schemeClr val="bg1"/>
+                </a:solidFill>
+              </a:rPr>
+              <a:t>nog LSB-a? </a:t>
+            </a:r>
+            <a:endParaRPr lang="en-US" altLang="en-US" sz="2000" b="1">
+              <a:solidFill>
+                <a:schemeClr val="bg1"/>
+              </a:solidFill>
+            </a:endParaRPr>
+          </a:p>
+          <a:p>
+            <a:pPr marL="285750" indent="-285750">
+              <a:buFont typeface="Wingdings" panose="05000000000000000000" charset="0"/>
+              <a:buChar char="v"/>
+            </a:pPr>
+            <a:endParaRPr lang="en-US" altLang="en-US" sz="2000">
+              <a:solidFill>
+                <a:schemeClr val="bg1"/>
+              </a:solidFill>
+            </a:endParaRPr>
+          </a:p>
+          <a:p>
+            <a:pPr marL="285750" indent="-285750">
+              <a:buFont typeface="Wingdings" panose="05000000000000000000" charset="0"/>
+              <a:buChar char="v"/>
+            </a:pPr>
+            <a:r>
+              <a:rPr lang="en-US" altLang="en-US" sz="2000" b="1">
+                <a:solidFill>
+                  <a:schemeClr val="bg1"/>
+                </a:solidFill>
+              </a:rPr>
+              <a:t>Rezultat: Globalni Hi-kvadrat test sa po</a:t>
+            </a:r>
+            <a:r>
+              <a:rPr lang="en-US" altLang="en-US" sz="2000" b="1">
+                <a:solidFill>
+                  <a:schemeClr val="bg1"/>
+                </a:solidFill>
+              </a:rPr>
+              <a:t>č</a:t>
+            </a:r>
+            <a:r>
+              <a:rPr lang="en-US" altLang="en-US" sz="2000" b="1">
+                <a:solidFill>
+                  <a:schemeClr val="bg1"/>
+                </a:solidFill>
+              </a:rPr>
+              <a:t>etka slike vi</a:t>
+            </a:r>
+            <a:r>
+              <a:rPr lang="en-US" altLang="en-US" sz="2000" b="1">
+                <a:solidFill>
+                  <a:schemeClr val="bg1"/>
+                </a:solidFill>
+              </a:rPr>
+              <a:t>š</a:t>
+            </a:r>
+            <a:r>
+              <a:rPr lang="en-US" altLang="en-US" sz="2000" b="1">
+                <a:solidFill>
+                  <a:schemeClr val="bg1"/>
+                </a:solidFill>
+              </a:rPr>
+              <a:t>e ne vidi anomaliju jer je </a:t>
+            </a:r>
+            <a:r>
+              <a:rPr lang="en-US" altLang="en-US" sz="2000" b="1">
+                <a:solidFill>
+                  <a:schemeClr val="bg1"/>
+                </a:solidFill>
+              </a:rPr>
+              <a:t>š</a:t>
+            </a:r>
+            <a:r>
+              <a:rPr lang="en-US" altLang="en-US" sz="2000" b="1">
+                <a:solidFill>
+                  <a:schemeClr val="bg1"/>
+                </a:solidFill>
+              </a:rPr>
+              <a:t>um previ</a:t>
+            </a:r>
+            <a:r>
+              <a:rPr lang="en-US" altLang="en-US" sz="2000" b="1">
+                <a:solidFill>
+                  <a:schemeClr val="bg1"/>
+                </a:solidFill>
+              </a:rPr>
+              <a:t>š</a:t>
+            </a:r>
+            <a:r>
+              <a:rPr lang="en-US" altLang="en-US" sz="2000" b="1">
+                <a:solidFill>
+                  <a:schemeClr val="bg1"/>
+                </a:solidFill>
+              </a:rPr>
+              <a:t>e razvu</a:t>
+            </a:r>
+            <a:r>
+              <a:rPr lang="en-US" altLang="en-US" sz="2000" b="1">
+                <a:solidFill>
+                  <a:schemeClr val="bg1"/>
+                </a:solidFill>
+              </a:rPr>
+              <a:t>č</a:t>
+            </a:r>
+            <a:r>
+              <a:rPr lang="en-US" altLang="en-US" sz="2000" b="1">
+                <a:solidFill>
+                  <a:schemeClr val="bg1"/>
+                </a:solidFill>
+              </a:rPr>
+              <a:t>en.</a:t>
+            </a:r>
+            <a:endParaRPr lang="en-US" altLang="en-US" sz="2000" b="1">
+              <a:solidFill>
+                <a:schemeClr val="bg1"/>
+              </a:solidFill>
+            </a:endParaRPr>
+          </a:p>
+          <a:p>
+            <a:pPr marL="285750" indent="-285750">
+              <a:buFont typeface="Wingdings" panose="05000000000000000000" charset="0"/>
+              <a:buChar char="v"/>
+            </a:pPr>
+            <a:endParaRPr lang="en-US" altLang="en-US" sz="2000">
+              <a:solidFill>
+                <a:schemeClr val="bg1"/>
+              </a:solidFill>
+            </a:endParaRPr>
+          </a:p>
+          <a:p>
+            <a:pPr marL="285750" indent="-285750">
+              <a:buFont typeface="Wingdings" panose="05000000000000000000" charset="0"/>
+              <a:buChar char="v"/>
+            </a:pPr>
+            <a:r>
+              <a:rPr lang="en-US" altLang="en-US" sz="2000" b="1">
+                <a:solidFill>
+                  <a:schemeClr val="bg1"/>
+                </a:solidFill>
+              </a:rPr>
+              <a:t>Kako ipak pada? </a:t>
+            </a:r>
+            <a:r>
+              <a:rPr lang="sr-Latn-RS" altLang="en-US" sz="2000" b="1">
+                <a:solidFill>
+                  <a:schemeClr val="bg1"/>
+                </a:solidFill>
+              </a:rPr>
+              <a:t>(Sliding window)</a:t>
+            </a:r>
+            <a:endParaRPr lang="sr-Latn-RS" altLang="en-US" sz="2000" b="1">
+              <a:solidFill>
+                <a:schemeClr val="bg1"/>
+              </a:solidFill>
+            </a:endParaRPr>
+          </a:p>
+        </p:txBody>
+      </p:sp>
+    </p:spTree>
+  </p:cSld>
+  <p:clrMapOvr>
+    <a:masterClrMapping/>
+  </p:clrMapOvr>
+</p:sld>
+</file>
+
+<file path=ppt/slides/slide11.xml><?xml version="1.0" encoding="utf-8"?>
+<p:sld xmlns:a="http://schemas.openxmlformats.org/drawingml/2006/main" xmlns:r="http://schemas.openxmlformats.org/officeDocument/2006/relationships" xmlns:p="http://schemas.openxmlformats.org/presentationml/2006/main">
+  <p:cSld>
+    <p:spTree>
+      <p:nvGrpSpPr>
+        <p:cNvPr id="1" name=""/>
+        <p:cNvGrpSpPr/>
+        <p:nvPr/>
+      </p:nvGrpSpPr>
+      <p:grpSpPr/>
+      <p:sp>
+        <p:nvSpPr>
+          <p:cNvPr id="2" name="Title 1"/>
+          <p:cNvSpPr>
+            <a:spLocks noGrp="1"/>
+          </p:cNvSpPr>
+          <p:nvPr>
+            <p:ph type="title"/>
+          </p:nvPr>
+        </p:nvSpPr>
+        <p:spPr/>
+        <p:txBody>
+          <a:bodyPr/>
+          <a:p>
+            <a:pPr algn="ctr"/>
+            <a:r>
+              <a:rPr lang="en-US" altLang="en-US"/>
+              <a:t>OutGuess 0.2 i F5</a:t>
+            </a:r>
+            <a:endParaRPr lang="en-US" altLang="en-US"/>
+          </a:p>
+        </p:txBody>
+      </p:sp>
+      <p:sp>
+        <p:nvSpPr>
+          <p:cNvPr id="3" name="Text Box 2"/>
+          <p:cNvSpPr txBox="1"/>
+          <p:nvPr/>
+        </p:nvSpPr>
+        <p:spPr>
+          <a:xfrm>
+            <a:off x="2494280" y="2251075"/>
+            <a:ext cx="7204075" cy="2861310"/>
+          </a:xfrm>
+          <a:prstGeom prst="rect">
+            <a:avLst/>
+          </a:prstGeom>
+          <a:noFill/>
+        </p:spPr>
+        <p:txBody>
+          <a:bodyPr wrap="square" rtlCol="0">
+            <a:spAutoFit/>
+          </a:bodyPr>
+          <a:p>
+            <a:pPr marL="285750" indent="-285750">
+              <a:buFont typeface="Wingdings" panose="05000000000000000000" charset="0"/>
+              <a:buChar char="v"/>
+            </a:pPr>
+            <a:r>
+              <a:rPr lang="en-US" altLang="en-US" sz="2000" b="1">
+                <a:solidFill>
+                  <a:schemeClr val="bg1"/>
+                </a:solidFill>
+              </a:rPr>
+              <a:t>OutGuess 0.2 – Korektivne transformacije:</a:t>
+            </a:r>
+            <a:endParaRPr lang="en-US" altLang="en-US" sz="2000" b="1">
+              <a:solidFill>
+                <a:schemeClr val="bg1"/>
+              </a:solidFill>
+            </a:endParaRPr>
+          </a:p>
+          <a:p>
+            <a:pPr marL="285750" indent="-285750">
+              <a:buFont typeface="Wingdings" panose="05000000000000000000" charset="0"/>
+              <a:buChar char="v"/>
+            </a:pPr>
+            <a:endParaRPr lang="en-US" altLang="en-US" sz="2000" b="1">
+              <a:solidFill>
+                <a:schemeClr val="bg1"/>
+              </a:solidFill>
+            </a:endParaRPr>
+          </a:p>
+          <a:p>
+            <a:pPr marL="742950" lvl="1" indent="-285750">
+              <a:buFont typeface="Wingdings" panose="05000000000000000000" charset="0"/>
+              <a:buChar char="v"/>
+            </a:pPr>
+            <a:r>
+              <a:rPr lang="en-US" altLang="en-US" sz="2000" b="1">
+                <a:solidFill>
+                  <a:schemeClr val="bg1"/>
+                </a:solidFill>
+              </a:rPr>
+              <a:t>Ideja</a:t>
+            </a:r>
+            <a:r>
+              <a:rPr lang="sr-Latn-RS" altLang="en-US" sz="2000" b="1">
+                <a:solidFill>
+                  <a:schemeClr val="bg1"/>
+                </a:solidFill>
+              </a:rPr>
+              <a:t> (Veštačka popravka histograma)</a:t>
+            </a:r>
+            <a:endParaRPr lang="en-US" altLang="en-US" sz="2000" b="1">
+              <a:solidFill>
+                <a:schemeClr val="bg1"/>
+              </a:solidFill>
+            </a:endParaRPr>
+          </a:p>
+          <a:p>
+            <a:pPr marL="285750" indent="-285750">
+              <a:buFont typeface="Wingdings" panose="05000000000000000000" charset="0"/>
+              <a:buChar char="v"/>
+            </a:pPr>
+            <a:endParaRPr lang="en-US" altLang="en-US" sz="2000" b="1">
+              <a:solidFill>
+                <a:schemeClr val="bg1"/>
+              </a:solidFill>
+            </a:endParaRPr>
+          </a:p>
+          <a:p>
+            <a:pPr marL="285750" indent="-285750">
+              <a:buFont typeface="Wingdings" panose="05000000000000000000" charset="0"/>
+              <a:buChar char="v"/>
+            </a:pPr>
+            <a:r>
+              <a:rPr lang="en-US" altLang="en-US" sz="2000" b="1">
+                <a:solidFill>
+                  <a:schemeClr val="bg1"/>
+                </a:solidFill>
+              </a:rPr>
+              <a:t>F5 – Matri</a:t>
+            </a:r>
+            <a:r>
+              <a:rPr lang="en-US" altLang="en-US" sz="2000" b="1">
+                <a:solidFill>
+                  <a:schemeClr val="bg1"/>
+                </a:solidFill>
+              </a:rPr>
+              <a:t>č</a:t>
+            </a:r>
+            <a:r>
+              <a:rPr lang="en-US" altLang="en-US" sz="2000" b="1">
+                <a:solidFill>
+                  <a:schemeClr val="bg1"/>
+                </a:solidFill>
+              </a:rPr>
+              <a:t>no kodiranje (Hammingov kod):</a:t>
+            </a:r>
+            <a:endParaRPr lang="en-US" altLang="en-US" sz="2000" b="1">
+              <a:solidFill>
+                <a:schemeClr val="bg1"/>
+              </a:solidFill>
+            </a:endParaRPr>
+          </a:p>
+          <a:p>
+            <a:pPr marL="285750" indent="-285750">
+              <a:buFont typeface="Wingdings" panose="05000000000000000000" charset="0"/>
+              <a:buChar char="v"/>
+            </a:pPr>
+            <a:endParaRPr lang="en-US" altLang="en-US" sz="2000" b="1">
+              <a:solidFill>
+                <a:schemeClr val="bg1"/>
+              </a:solidFill>
+            </a:endParaRPr>
+          </a:p>
+          <a:p>
+            <a:pPr marL="742950" lvl="1" indent="-285750">
+              <a:buFont typeface="Wingdings" panose="05000000000000000000" charset="0"/>
+              <a:buChar char="v"/>
+            </a:pPr>
+            <a:r>
+              <a:rPr lang="en-US" altLang="en-US" sz="2000" b="1">
+                <a:solidFill>
+                  <a:schemeClr val="bg1"/>
+                </a:solidFill>
+              </a:rPr>
+              <a:t>Ideja: </a:t>
+            </a:r>
+            <a:r>
+              <a:rPr lang="sr-Latn-RS" altLang="en-US" sz="2000" b="1">
+                <a:solidFill>
+                  <a:schemeClr val="bg1"/>
+                </a:solidFill>
+              </a:rPr>
+              <a:t>Oduzimanje bitova</a:t>
+            </a:r>
+            <a:endParaRPr lang="en-US" altLang="en-US" sz="2000" b="1">
+              <a:solidFill>
+                <a:schemeClr val="bg1"/>
+              </a:solidFill>
+            </a:endParaRPr>
+          </a:p>
+          <a:p>
+            <a:pPr marL="285750" indent="-285750">
+              <a:buFont typeface="Wingdings" panose="05000000000000000000" charset="0"/>
+              <a:buChar char="v"/>
+            </a:pPr>
+            <a:endParaRPr lang="en-US" altLang="en-US" sz="2000" b="1">
+              <a:solidFill>
+                <a:schemeClr val="bg1"/>
+              </a:solidFill>
+            </a:endParaRPr>
+          </a:p>
+          <a:p>
+            <a:pPr marL="742950" lvl="1" indent="-285750">
+              <a:buFont typeface="Wingdings" panose="05000000000000000000" charset="0"/>
+              <a:buChar char="v"/>
+            </a:pPr>
+            <a:r>
+              <a:rPr lang="en-US" altLang="en-US" sz="2000" b="1">
+                <a:solidFill>
+                  <a:schemeClr val="bg1"/>
+                </a:solidFill>
+              </a:rPr>
+              <a:t>Efekat: </a:t>
+            </a:r>
+            <a:r>
+              <a:rPr lang="sr-Latn-RS" altLang="en-US" sz="2000" b="1">
+                <a:solidFill>
+                  <a:schemeClr val="bg1"/>
+                </a:solidFill>
+              </a:rPr>
+              <a:t>Upis veće količine podataka sa manjim izmenama</a:t>
+            </a:r>
+            <a:endParaRPr lang="sr-Latn-RS" altLang="en-US" sz="2000" b="1">
+              <a:solidFill>
+                <a:schemeClr val="bg1"/>
+              </a:solidFill>
+            </a:endParaRPr>
+          </a:p>
+        </p:txBody>
+      </p:sp>
+    </p:spTree>
+  </p:cSld>
+  <p:clrMapOvr>
+    <a:masterClrMapping/>
+  </p:clrMapOvr>
+</p:sld>
+</file>
+
+<file path=ppt/slides/slide12.xml><?xml version="1.0" encoding="utf-8"?>
+<p:sld xmlns:a="http://schemas.openxmlformats.org/drawingml/2006/main" xmlns:r="http://schemas.openxmlformats.org/officeDocument/2006/relationships" xmlns:p="http://schemas.openxmlformats.org/presentationml/2006/main">
+  <p:cSld>
+    <p:spTree>
+      <p:nvGrpSpPr>
+        <p:cNvPr id="1" name=""/>
+        <p:cNvGrpSpPr/>
+        <p:nvPr/>
+      </p:nvGrpSpPr>
+      <p:grpSpPr/>
+      <p:sp>
+        <p:nvSpPr>
           <p:cNvPr id="14338" name="文本占位符 2"/>
           <p:cNvSpPr>
             <a:spLocks noGrp="1"/>
@@ -4968,7 +5504,7 @@
 </p:sld>
 </file>
 
-<file path=ppt/slides/slide11.xml><?xml version="1.0" encoding="utf-8"?>
+<file path=ppt/slides/slide13.xml><?xml version="1.0" encoding="utf-8"?>
 <p:sld xmlns:a="http://schemas.openxmlformats.org/drawingml/2006/main" xmlns:r="http://schemas.openxmlformats.org/officeDocument/2006/relationships" xmlns:p="http://schemas.openxmlformats.org/presentationml/2006/main">
   <p:cSld>
     <p:spTree>
@@ -5383,7 +5919,7 @@
 </p:sld>
 </file>
 
-<file path=ppt/slides/slide12.xml><?xml version="1.0" encoding="utf-8"?>
+<file path=ppt/slides/slide14.xml><?xml version="1.0" encoding="utf-8"?>
 <p:sld xmlns:a="http://schemas.openxmlformats.org/drawingml/2006/main" xmlns:r="http://schemas.openxmlformats.org/officeDocument/2006/relationships" xmlns:p="http://schemas.openxmlformats.org/presentationml/2006/main">
   <p:cSld>
     <p:spTree>
@@ -6131,7 +6667,7 @@
 </p:sld>
 </file>
 
-<file path=ppt/slides/slide13.xml><?xml version="1.0" encoding="utf-8"?>
+<file path=ppt/slides/slide15.xml><?xml version="1.0" encoding="utf-8"?>
 <p:sld xmlns:a="http://schemas.openxmlformats.org/drawingml/2006/main" xmlns:r="http://schemas.openxmlformats.org/officeDocument/2006/relationships" xmlns:p="http://schemas.openxmlformats.org/presentationml/2006/main">
   <p:cSld>
     <p:spTree>
@@ -7022,7 +7558,7 @@
 </p:sld>
 </file>
 
-<file path=ppt/slides/slide14.xml><?xml version="1.0" encoding="utf-8"?>
+<file path=ppt/slides/slide16.xml><?xml version="1.0" encoding="utf-8"?>
 <p:sld xmlns:a="http://schemas.openxmlformats.org/drawingml/2006/main" xmlns:r="http://schemas.openxmlformats.org/officeDocument/2006/relationships" xmlns:p="http://schemas.openxmlformats.org/presentationml/2006/main">
   <p:cSld>
     <p:spTree>
@@ -8715,7 +9251,7 @@
 </p:sld>
 </file>
 
-<file path=ppt/slides/slide15.xml><?xml version="1.0" encoding="utf-8"?>
+<file path=ppt/slides/slide17.xml><?xml version="1.0" encoding="utf-8"?>
 <p:sld xmlns:a="http://schemas.openxmlformats.org/drawingml/2006/main" xmlns:r="http://schemas.openxmlformats.org/officeDocument/2006/relationships" xmlns:p="http://schemas.openxmlformats.org/presentationml/2006/main">
   <p:cSld>
     <p:spTree>
@@ -13595,7 +14131,7 @@
 </p:sld>
 </file>
 
-<file path=ppt/slides/slide16.xml><?xml version="1.0" encoding="utf-8"?>
+<file path=ppt/slides/slide18.xml><?xml version="1.0" encoding="utf-8"?>
 <p:sld xmlns:a="http://schemas.openxmlformats.org/drawingml/2006/main" xmlns:r="http://schemas.openxmlformats.org/officeDocument/2006/relationships" xmlns:p="http://schemas.openxmlformats.org/presentationml/2006/main">
   <p:cSld>
     <p:spTree>
@@ -16374,7 +16910,7 @@
 </p:sld>
 </file>
 
-<file path=ppt/slides/slide17.xml><?xml version="1.0" encoding="utf-8"?>
+<file path=ppt/slides/slide19.xml><?xml version="1.0" encoding="utf-8"?>
 <p:sld xmlns:a="http://schemas.openxmlformats.org/drawingml/2006/main" xmlns:r="http://schemas.openxmlformats.org/officeDocument/2006/relationships" xmlns:p="http://schemas.openxmlformats.org/presentationml/2006/main">
   <p:cSld>
     <p:spTree>
@@ -18582,7 +19118,440 @@
 </p:sld>
 </file>
 
-<file path=ppt/slides/slide18.xml><?xml version="1.0" encoding="utf-8"?>
+<file path=ppt/slides/slide2.xml><?xml version="1.0" encoding="utf-8"?>
+<p:sld xmlns:a="http://schemas.openxmlformats.org/drawingml/2006/main" xmlns:r="http://schemas.openxmlformats.org/officeDocument/2006/relationships" xmlns:p="http://schemas.openxmlformats.org/presentationml/2006/main">
+  <p:cSld>
+    <p:spTree>
+      <p:nvGrpSpPr>
+        <p:cNvPr id="1" name=""/>
+        <p:cNvGrpSpPr/>
+        <p:nvPr/>
+      </p:nvGrpSpPr>
+      <p:grpSpPr/>
+      <p:sp>
+        <p:nvSpPr>
+          <p:cNvPr id="4" name="标题 3"/>
+          <p:cNvSpPr>
+            <a:spLocks noGrp="1"/>
+          </p:cNvSpPr>
+          <p:nvPr>
+            <p:ph type="title"/>
+          </p:nvPr>
+        </p:nvSpPr>
+        <p:spPr/>
+        <p:txBody>
+          <a:bodyPr vert="horz" lIns="91440" tIns="45720" rIns="91440" bIns="45720" rtlCol="0" anchor="ctr">
+            <a:normAutofit/>
+          </a:bodyPr>
+          <a:lstStyle/>
+          <a:p>
+            <a:pPr marL="0" marR="0" lvl="0" indent="0" algn="l" defTabSz="914400" rtl="0" eaLnBrk="1" fontAlgn="auto" latinLnBrk="0" hangingPunct="1">
+              <a:lnSpc>
+                <a:spcPct val="90000"/>
+              </a:lnSpc>
+              <a:spcBef>
+                <a:spcPct val="0"/>
+              </a:spcBef>
+              <a:spcAft>
+                <a:spcPts val="0"/>
+              </a:spcAft>
+              <a:buClrTx/>
+              <a:buSzTx/>
+              <a:buFontTx/>
+              <a:buNone/>
+              <a:defRPr/>
+            </a:pPr>
+            <a:r>
+              <a:rPr lang="en-US" altLang="en-US" dirty="0">
+                <a:sym typeface="+mn-ea"/>
+              </a:rPr>
+              <a:t>Šta je steganografija?</a:t>
+            </a:r>
+            <a:endParaRPr kumimoji="0" lang="zh-CN" altLang="en-US" sz="4400" b="0" i="0" u="none" strike="noStrike" kern="1200" cap="none" spc="0" normalizeH="0" baseline="0" noProof="0" dirty="0">
+              <a:ln>
+                <a:noFill/>
+              </a:ln>
+              <a:solidFill>
+                <a:schemeClr val="bg1"/>
+              </a:solidFill>
+              <a:effectLst/>
+              <a:uLnTx/>
+              <a:uFillTx/>
+              <a:latin typeface="+mj-lt"/>
+              <a:ea typeface="+mj-ea"/>
+              <a:cs typeface="+mj-cs"/>
+            </a:endParaRPr>
+          </a:p>
+        </p:txBody>
+      </p:sp>
+      <p:sp>
+        <p:nvSpPr>
+          <p:cNvPr id="9" name="矩形 8"/>
+          <p:cNvSpPr/>
+          <p:nvPr/>
+        </p:nvSpPr>
+        <p:spPr>
+          <a:xfrm>
+            <a:off x="8197850" y="1808480"/>
+            <a:ext cx="3894455" cy="4655185"/>
+          </a:xfrm>
+          <a:prstGeom prst="rect">
+            <a:avLst/>
+          </a:prstGeom>
+          <a:solidFill>
+            <a:srgbClr val="1C7C5A"/>
+          </a:solidFill>
+          <a:ln>
+            <a:noFill/>
+          </a:ln>
+        </p:spPr>
+        <p:style>
+          <a:lnRef idx="2">
+            <a:schemeClr val="accent1">
+              <a:shade val="50000"/>
+            </a:schemeClr>
+          </a:lnRef>
+          <a:fillRef idx="1">
+            <a:schemeClr val="accent1"/>
+          </a:fillRef>
+          <a:effectRef idx="0">
+            <a:schemeClr val="accent1"/>
+          </a:effectRef>
+          <a:fontRef idx="minor">
+            <a:schemeClr val="lt1"/>
+          </a:fontRef>
+        </p:style>
+        <p:txBody>
+          <a:bodyPr rtlCol="0" anchor="ctr"/>
+          <a:lstStyle/>
+          <a:p>
+            <a:pPr marL="0" marR="0" lvl="0" indent="0" algn="ctr" defTabSz="914400" rtl="0" eaLnBrk="1" fontAlgn="auto" latinLnBrk="0" hangingPunct="1">
+              <a:lnSpc>
+                <a:spcPct val="100000"/>
+              </a:lnSpc>
+              <a:spcBef>
+                <a:spcPts val="0"/>
+              </a:spcBef>
+              <a:spcAft>
+                <a:spcPts val="0"/>
+              </a:spcAft>
+              <a:buClrTx/>
+              <a:buSzTx/>
+              <a:buFontTx/>
+              <a:buNone/>
+              <a:defRPr/>
+            </a:pPr>
+            <a:endParaRPr kumimoji="0" lang="zh-CN" altLang="en-US" sz="1800" b="0" i="0" u="none" strike="noStrike" kern="1200" cap="none" spc="0" normalizeH="0" baseline="0" noProof="0">
+              <a:ln>
+                <a:noFill/>
+              </a:ln>
+              <a:solidFill>
+                <a:schemeClr val="bg1"/>
+              </a:solidFill>
+              <a:effectLst/>
+              <a:uLnTx/>
+              <a:uFillTx/>
+              <a:latin typeface="+mn-lt"/>
+              <a:ea typeface="+mn-ea"/>
+              <a:cs typeface="+mn-cs"/>
+            </a:endParaRPr>
+          </a:p>
+        </p:txBody>
+      </p:sp>
+      <p:sp>
+        <p:nvSpPr>
+          <p:cNvPr id="9223" name="矩形 9"/>
+          <p:cNvSpPr/>
+          <p:nvPr/>
+        </p:nvSpPr>
+        <p:spPr>
+          <a:xfrm>
+            <a:off x="8197850" y="1911985"/>
+            <a:ext cx="3894455" cy="4551680"/>
+          </a:xfrm>
+          <a:prstGeom prst="rect">
+            <a:avLst/>
+          </a:prstGeom>
+          <a:noFill/>
+          <a:ln w="9525">
+            <a:noFill/>
+          </a:ln>
+        </p:spPr>
+        <p:txBody>
+          <a:bodyPr wrap="square" anchor="t" anchorCtr="0">
+            <a:noAutofit/>
+          </a:bodyPr>
+          <a:p>
+            <a:pPr marL="342900" indent="-342900" algn="just">
+              <a:buFont typeface="Wingdings" panose="05000000000000000000" charset="0"/>
+              <a:buChar char="v"/>
+            </a:pPr>
+            <a:r>
+              <a:rPr lang="en-US" altLang="en-US" sz="2000" dirty="0">
+                <a:solidFill>
+                  <a:schemeClr val="bg1"/>
+                </a:solidFill>
+                <a:latin typeface="Calibri" panose="020F0502020204030204" pitchFamily="34" charset="0"/>
+                <a:ea typeface="Microsoft YaHei Light" panose="020B0502040204020203" pitchFamily="34" charset="-122"/>
+              </a:rPr>
+              <a:t>Steganografija je tehnika skrivanja poruke unutar drugog digitalnog sadr</a:t>
+            </a:r>
+            <a:r>
+              <a:rPr lang="en-US" altLang="en-US" sz="2000" dirty="0">
+                <a:solidFill>
+                  <a:schemeClr val="bg1"/>
+                </a:solidFill>
+                <a:latin typeface="Calibri" panose="020F0502020204030204" pitchFamily="34" charset="0"/>
+                <a:ea typeface="Microsoft YaHei Light" panose="020B0502040204020203" pitchFamily="34" charset="-122"/>
+              </a:rPr>
+              <a:t>ž</a:t>
+            </a:r>
+            <a:r>
+              <a:rPr lang="en-US" altLang="en-US" sz="2000" dirty="0">
+                <a:solidFill>
+                  <a:schemeClr val="bg1"/>
+                </a:solidFill>
+                <a:latin typeface="Calibri" panose="020F0502020204030204" pitchFamily="34" charset="0"/>
+                <a:ea typeface="Microsoft YaHei Light" panose="020B0502040204020203" pitchFamily="34" charset="-122"/>
+              </a:rPr>
+              <a:t>aja.</a:t>
+            </a:r>
+            <a:endParaRPr lang="en-US" altLang="en-US" sz="2000" dirty="0">
+              <a:solidFill>
+                <a:schemeClr val="bg1"/>
+              </a:solidFill>
+              <a:latin typeface="Calibri" panose="020F0502020204030204" pitchFamily="34" charset="0"/>
+              <a:ea typeface="Microsoft YaHei Light" panose="020B0502040204020203" pitchFamily="34" charset="-122"/>
+            </a:endParaRPr>
+          </a:p>
+          <a:p>
+            <a:pPr marL="342900" indent="-342900" algn="just">
+              <a:buFont typeface="Wingdings" panose="05000000000000000000" charset="0"/>
+              <a:buChar char="v"/>
+            </a:pPr>
+            <a:endParaRPr lang="en-US" altLang="en-US" sz="2000" dirty="0">
+              <a:solidFill>
+                <a:schemeClr val="bg1"/>
+              </a:solidFill>
+              <a:latin typeface="Calibri" panose="020F0502020204030204" pitchFamily="34" charset="0"/>
+              <a:ea typeface="Microsoft YaHei Light" panose="020B0502040204020203" pitchFamily="34" charset="-122"/>
+            </a:endParaRPr>
+          </a:p>
+          <a:p>
+            <a:pPr marL="342900" indent="-342900" algn="just">
+              <a:buFont typeface="Wingdings" panose="05000000000000000000" charset="0"/>
+              <a:buChar char="v"/>
+            </a:pPr>
+            <a:r>
+              <a:rPr lang="en-US" altLang="en-US" sz="2000" dirty="0">
+                <a:solidFill>
+                  <a:schemeClr val="bg1"/>
+                </a:solidFill>
+                <a:latin typeface="Calibri" panose="020F0502020204030204" pitchFamily="34" charset="0"/>
+                <a:ea typeface="Microsoft YaHei Light" panose="020B0502040204020203" pitchFamily="34" charset="-122"/>
+              </a:rPr>
+              <a:t>Cilj nije samo za</a:t>
+            </a:r>
+            <a:r>
+              <a:rPr lang="en-US" altLang="en-US" sz="2000" dirty="0">
+                <a:solidFill>
+                  <a:schemeClr val="bg1"/>
+                </a:solidFill>
+                <a:latin typeface="Calibri" panose="020F0502020204030204" pitchFamily="34" charset="0"/>
+                <a:ea typeface="Microsoft YaHei Light" panose="020B0502040204020203" pitchFamily="34" charset="-122"/>
+              </a:rPr>
+              <a:t>š</a:t>
+            </a:r>
+            <a:r>
+              <a:rPr lang="en-US" altLang="en-US" sz="2000" dirty="0">
+                <a:solidFill>
+                  <a:schemeClr val="bg1"/>
+                </a:solidFill>
+                <a:latin typeface="Calibri" panose="020F0502020204030204" pitchFamily="34" charset="0"/>
+                <a:ea typeface="Microsoft YaHei Light" panose="020B0502040204020203" pitchFamily="34" charset="-122"/>
+              </a:rPr>
+              <a:t>tita sadr</a:t>
+            </a:r>
+            <a:r>
+              <a:rPr lang="en-US" altLang="en-US" sz="2000" dirty="0">
+                <a:solidFill>
+                  <a:schemeClr val="bg1"/>
+                </a:solidFill>
+                <a:latin typeface="Calibri" panose="020F0502020204030204" pitchFamily="34" charset="0"/>
+                <a:ea typeface="Microsoft YaHei Light" panose="020B0502040204020203" pitchFamily="34" charset="-122"/>
+              </a:rPr>
+              <a:t>ž</a:t>
+            </a:r>
+            <a:r>
+              <a:rPr lang="en-US" altLang="en-US" sz="2000" dirty="0">
+                <a:solidFill>
+                  <a:schemeClr val="bg1"/>
+                </a:solidFill>
+                <a:latin typeface="Calibri" panose="020F0502020204030204" pitchFamily="34" charset="0"/>
+                <a:ea typeface="Microsoft YaHei Light" panose="020B0502040204020203" pitchFamily="34" charset="-122"/>
+              </a:rPr>
+              <a:t>aja poruke, ve</a:t>
+            </a:r>
+            <a:r>
+              <a:rPr lang="en-US" altLang="en-US" sz="2000" dirty="0">
+                <a:solidFill>
+                  <a:schemeClr val="bg1"/>
+                </a:solidFill>
+                <a:latin typeface="Calibri" panose="020F0502020204030204" pitchFamily="34" charset="0"/>
+                <a:ea typeface="Microsoft YaHei Light" panose="020B0502040204020203" pitchFamily="34" charset="-122"/>
+              </a:rPr>
+              <a:t>ć </a:t>
+            </a:r>
+            <a:r>
+              <a:rPr lang="en-US" altLang="en-US" sz="2000" dirty="0">
+                <a:solidFill>
+                  <a:schemeClr val="bg1"/>
+                </a:solidFill>
+                <a:latin typeface="Calibri" panose="020F0502020204030204" pitchFamily="34" charset="0"/>
+                <a:ea typeface="Microsoft YaHei Light" panose="020B0502040204020203" pitchFamily="34" charset="-122"/>
+              </a:rPr>
+              <a:t>i skrivanje njenog postojanja.</a:t>
+            </a:r>
+            <a:endParaRPr lang="en-US" altLang="en-US" sz="2000" dirty="0">
+              <a:solidFill>
+                <a:schemeClr val="bg1"/>
+              </a:solidFill>
+              <a:latin typeface="Calibri" panose="020F0502020204030204" pitchFamily="34" charset="0"/>
+              <a:ea typeface="Microsoft YaHei Light" panose="020B0502040204020203" pitchFamily="34" charset="-122"/>
+            </a:endParaRPr>
+          </a:p>
+          <a:p>
+            <a:pPr marL="342900" indent="-342900" algn="just">
+              <a:buFont typeface="Wingdings" panose="05000000000000000000" charset="0"/>
+              <a:buChar char="v"/>
+            </a:pPr>
+            <a:endParaRPr lang="en-US" altLang="en-US" sz="2000" dirty="0">
+              <a:solidFill>
+                <a:schemeClr val="bg1"/>
+              </a:solidFill>
+              <a:latin typeface="Calibri" panose="020F0502020204030204" pitchFamily="34" charset="0"/>
+              <a:ea typeface="Microsoft YaHei Light" panose="020B0502040204020203" pitchFamily="34" charset="-122"/>
+            </a:endParaRPr>
+          </a:p>
+          <a:p>
+            <a:pPr marL="342900" indent="-342900" algn="just">
+              <a:buFont typeface="Wingdings" panose="05000000000000000000" charset="0"/>
+              <a:buChar char="v"/>
+            </a:pPr>
+            <a:r>
+              <a:rPr lang="en-US" altLang="en-US" sz="2000" dirty="0">
+                <a:solidFill>
+                  <a:schemeClr val="bg1"/>
+                </a:solidFill>
+                <a:latin typeface="Calibri" panose="020F0502020204030204" pitchFamily="34" charset="0"/>
+                <a:ea typeface="Microsoft YaHei Light" panose="020B0502040204020203" pitchFamily="34" charset="-122"/>
+              </a:rPr>
+              <a:t>Poruka mo</a:t>
+            </a:r>
+            <a:r>
+              <a:rPr lang="en-US" altLang="en-US" sz="2000" dirty="0">
+                <a:solidFill>
+                  <a:schemeClr val="bg1"/>
+                </a:solidFill>
+                <a:latin typeface="Calibri" panose="020F0502020204030204" pitchFamily="34" charset="0"/>
+                <a:ea typeface="Microsoft YaHei Light" panose="020B0502040204020203" pitchFamily="34" charset="-122"/>
+              </a:rPr>
+              <a:t>ž</a:t>
+            </a:r>
+            <a:r>
+              <a:rPr lang="en-US" altLang="en-US" sz="2000" dirty="0">
+                <a:solidFill>
+                  <a:schemeClr val="bg1"/>
+                </a:solidFill>
+                <a:latin typeface="Calibri" panose="020F0502020204030204" pitchFamily="34" charset="0"/>
+                <a:ea typeface="Microsoft YaHei Light" panose="020B0502040204020203" pitchFamily="34" charset="-122"/>
+              </a:rPr>
+              <a:t>e biti sakrivena u slici, zvuku, videu ili drugom fajlu.</a:t>
+            </a:r>
+            <a:endParaRPr lang="en-US" altLang="en-US" sz="2000" dirty="0">
+              <a:solidFill>
+                <a:schemeClr val="bg1"/>
+              </a:solidFill>
+              <a:latin typeface="Calibri" panose="020F0502020204030204" pitchFamily="34" charset="0"/>
+              <a:ea typeface="Microsoft YaHei Light" panose="020B0502040204020203" pitchFamily="34" charset="-122"/>
+            </a:endParaRPr>
+          </a:p>
+          <a:p>
+            <a:pPr marL="342900" indent="-342900" algn="just">
+              <a:buFont typeface="Wingdings" panose="05000000000000000000" charset="0"/>
+              <a:buChar char="v"/>
+            </a:pPr>
+            <a:endParaRPr lang="en-US" altLang="en-US" sz="2000" dirty="0">
+              <a:solidFill>
+                <a:schemeClr val="bg1"/>
+              </a:solidFill>
+              <a:latin typeface="Calibri" panose="020F0502020204030204" pitchFamily="34" charset="0"/>
+              <a:ea typeface="Microsoft YaHei Light" panose="020B0502040204020203" pitchFamily="34" charset="-122"/>
+            </a:endParaRPr>
+          </a:p>
+          <a:p>
+            <a:pPr marL="342900" indent="-342900" algn="just">
+              <a:buFont typeface="Wingdings" panose="05000000000000000000" charset="0"/>
+              <a:buChar char="v"/>
+            </a:pPr>
+            <a:r>
+              <a:rPr lang="en-US" altLang="en-US" sz="2000" dirty="0">
+                <a:solidFill>
+                  <a:schemeClr val="bg1"/>
+                </a:solidFill>
+                <a:latin typeface="Calibri" panose="020F0502020204030204" pitchFamily="34" charset="0"/>
+                <a:ea typeface="Microsoft YaHei Light" panose="020B0502040204020203" pitchFamily="34" charset="-122"/>
+              </a:rPr>
+              <a:t>Rezultat je stego fajl, koji izgleda isto ili skoro isto kao original.</a:t>
+            </a:r>
+            <a:endParaRPr lang="en-US" altLang="en-US" sz="2000" dirty="0">
+              <a:solidFill>
+                <a:schemeClr val="bg1"/>
+              </a:solidFill>
+              <a:latin typeface="Calibri" panose="020F0502020204030204" pitchFamily="34" charset="0"/>
+              <a:ea typeface="Microsoft YaHei Light" panose="020B0502040204020203" pitchFamily="34" charset="-122"/>
+            </a:endParaRPr>
+          </a:p>
+        </p:txBody>
+      </p:sp>
+      <p:pic>
+        <p:nvPicPr>
+          <p:cNvPr id="9235" name="图片 37" descr="C:/Users/nikol/Downloads/steganography-1.jpgsteganography-1"/>
+          <p:cNvPicPr>
+            <a:picLocks noChangeAspect="1"/>
+          </p:cNvPicPr>
+          <p:nvPr/>
+        </p:nvPicPr>
+        <p:blipFill>
+          <a:blip r:embed="rId1"/>
+          <a:srcRect l="10284" r="10284"/>
+          <a:stretch>
+            <a:fillRect/>
+          </a:stretch>
+        </p:blipFill>
+        <p:spPr>
+          <a:xfrm>
+            <a:off x="840105" y="1808480"/>
+            <a:ext cx="7148195" cy="4655185"/>
+          </a:xfrm>
+          <a:prstGeom prst="rect">
+            <a:avLst/>
+          </a:prstGeom>
+          <a:noFill/>
+          <a:ln w="9525">
+            <a:noFill/>
+          </a:ln>
+        </p:spPr>
+      </p:pic>
+    </p:spTree>
+  </p:cSld>
+  <p:clrMapOvr>
+    <a:masterClrMapping/>
+  </p:clrMapOvr>
+</p:sld>
+</file>
+
+<file path=ppt/slides/slide20.xml><?xml version="1.0" encoding="utf-8"?>
 <p:sld xmlns:a="http://schemas.openxmlformats.org/drawingml/2006/main" xmlns:r="http://schemas.openxmlformats.org/officeDocument/2006/relationships" xmlns:p="http://schemas.openxmlformats.org/presentationml/2006/main">
   <p:cSld>
     <p:spTree>
@@ -18669,7 +19638,7 @@
 </p:sld>
 </file>
 
-<file path=ppt/slides/slide19.xml><?xml version="1.0" encoding="utf-8"?>
+<file path=ppt/slides/slide21.xml><?xml version="1.0" encoding="utf-8"?>
 <p:sld xmlns:a="http://schemas.openxmlformats.org/drawingml/2006/main" xmlns:r="http://schemas.openxmlformats.org/officeDocument/2006/relationships" xmlns:p="http://schemas.openxmlformats.org/presentationml/2006/main">
   <p:cSld>
     <p:spTree>
@@ -23737,440 +24706,7 @@
 </p:sld>
 </file>
 
-<file path=ppt/slides/slide2.xml><?xml version="1.0" encoding="utf-8"?>
-<p:sld xmlns:a="http://schemas.openxmlformats.org/drawingml/2006/main" xmlns:r="http://schemas.openxmlformats.org/officeDocument/2006/relationships" xmlns:p="http://schemas.openxmlformats.org/presentationml/2006/main">
-  <p:cSld>
-    <p:spTree>
-      <p:nvGrpSpPr>
-        <p:cNvPr id="1" name=""/>
-        <p:cNvGrpSpPr/>
-        <p:nvPr/>
-      </p:nvGrpSpPr>
-      <p:grpSpPr/>
-      <p:sp>
-        <p:nvSpPr>
-          <p:cNvPr id="4" name="标题 3"/>
-          <p:cNvSpPr>
-            <a:spLocks noGrp="1"/>
-          </p:cNvSpPr>
-          <p:nvPr>
-            <p:ph type="title"/>
-          </p:nvPr>
-        </p:nvSpPr>
-        <p:spPr/>
-        <p:txBody>
-          <a:bodyPr vert="horz" lIns="91440" tIns="45720" rIns="91440" bIns="45720" rtlCol="0" anchor="ctr">
-            <a:normAutofit/>
-          </a:bodyPr>
-          <a:lstStyle/>
-          <a:p>
-            <a:pPr marL="0" marR="0" lvl="0" indent="0" algn="l" defTabSz="914400" rtl="0" eaLnBrk="1" fontAlgn="auto" latinLnBrk="0" hangingPunct="1">
-              <a:lnSpc>
-                <a:spcPct val="90000"/>
-              </a:lnSpc>
-              <a:spcBef>
-                <a:spcPct val="0"/>
-              </a:spcBef>
-              <a:spcAft>
-                <a:spcPts val="0"/>
-              </a:spcAft>
-              <a:buClrTx/>
-              <a:buSzTx/>
-              <a:buFontTx/>
-              <a:buNone/>
-              <a:defRPr/>
-            </a:pPr>
-            <a:r>
-              <a:rPr lang="en-US" altLang="en-US" dirty="0">
-                <a:sym typeface="+mn-ea"/>
-              </a:rPr>
-              <a:t>Šta je steganografija?</a:t>
-            </a:r>
-            <a:endParaRPr kumimoji="0" lang="zh-CN" altLang="en-US" sz="4400" b="0" i="0" u="none" strike="noStrike" kern="1200" cap="none" spc="0" normalizeH="0" baseline="0" noProof="0" dirty="0">
-              <a:ln>
-                <a:noFill/>
-              </a:ln>
-              <a:solidFill>
-                <a:schemeClr val="bg1"/>
-              </a:solidFill>
-              <a:effectLst/>
-              <a:uLnTx/>
-              <a:uFillTx/>
-              <a:latin typeface="+mj-lt"/>
-              <a:ea typeface="+mj-ea"/>
-              <a:cs typeface="+mj-cs"/>
-            </a:endParaRPr>
-          </a:p>
-        </p:txBody>
-      </p:sp>
-      <p:sp>
-        <p:nvSpPr>
-          <p:cNvPr id="9" name="矩形 8"/>
-          <p:cNvSpPr/>
-          <p:nvPr/>
-        </p:nvSpPr>
-        <p:spPr>
-          <a:xfrm>
-            <a:off x="8197850" y="1808480"/>
-            <a:ext cx="3894455" cy="4655185"/>
-          </a:xfrm>
-          <a:prstGeom prst="rect">
-            <a:avLst/>
-          </a:prstGeom>
-          <a:solidFill>
-            <a:srgbClr val="1C7C5A"/>
-          </a:solidFill>
-          <a:ln>
-            <a:noFill/>
-          </a:ln>
-        </p:spPr>
-        <p:style>
-          <a:lnRef idx="2">
-            <a:schemeClr val="accent1">
-              <a:shade val="50000"/>
-            </a:schemeClr>
-          </a:lnRef>
-          <a:fillRef idx="1">
-            <a:schemeClr val="accent1"/>
-          </a:fillRef>
-          <a:effectRef idx="0">
-            <a:schemeClr val="accent1"/>
-          </a:effectRef>
-          <a:fontRef idx="minor">
-            <a:schemeClr val="lt1"/>
-          </a:fontRef>
-        </p:style>
-        <p:txBody>
-          <a:bodyPr rtlCol="0" anchor="ctr"/>
-          <a:lstStyle/>
-          <a:p>
-            <a:pPr marL="0" marR="0" lvl="0" indent="0" algn="ctr" defTabSz="914400" rtl="0" eaLnBrk="1" fontAlgn="auto" latinLnBrk="0" hangingPunct="1">
-              <a:lnSpc>
-                <a:spcPct val="100000"/>
-              </a:lnSpc>
-              <a:spcBef>
-                <a:spcPts val="0"/>
-              </a:spcBef>
-              <a:spcAft>
-                <a:spcPts val="0"/>
-              </a:spcAft>
-              <a:buClrTx/>
-              <a:buSzTx/>
-              <a:buFontTx/>
-              <a:buNone/>
-              <a:defRPr/>
-            </a:pPr>
-            <a:endParaRPr kumimoji="0" lang="zh-CN" altLang="en-US" sz="1800" b="0" i="0" u="none" strike="noStrike" kern="1200" cap="none" spc="0" normalizeH="0" baseline="0" noProof="0">
-              <a:ln>
-                <a:noFill/>
-              </a:ln>
-              <a:solidFill>
-                <a:schemeClr val="bg1"/>
-              </a:solidFill>
-              <a:effectLst/>
-              <a:uLnTx/>
-              <a:uFillTx/>
-              <a:latin typeface="+mn-lt"/>
-              <a:ea typeface="+mn-ea"/>
-              <a:cs typeface="+mn-cs"/>
-            </a:endParaRPr>
-          </a:p>
-        </p:txBody>
-      </p:sp>
-      <p:sp>
-        <p:nvSpPr>
-          <p:cNvPr id="9223" name="矩形 9"/>
-          <p:cNvSpPr/>
-          <p:nvPr/>
-        </p:nvSpPr>
-        <p:spPr>
-          <a:xfrm>
-            <a:off x="8197850" y="1911985"/>
-            <a:ext cx="3894455" cy="4551680"/>
-          </a:xfrm>
-          <a:prstGeom prst="rect">
-            <a:avLst/>
-          </a:prstGeom>
-          <a:noFill/>
-          <a:ln w="9525">
-            <a:noFill/>
-          </a:ln>
-        </p:spPr>
-        <p:txBody>
-          <a:bodyPr wrap="square" anchor="t" anchorCtr="0">
-            <a:noAutofit/>
-          </a:bodyPr>
-          <a:p>
-            <a:pPr marL="342900" indent="-342900" algn="just">
-              <a:buFont typeface="Wingdings" panose="05000000000000000000" charset="0"/>
-              <a:buChar char="v"/>
-            </a:pPr>
-            <a:r>
-              <a:rPr lang="en-US" altLang="en-US" sz="2000" dirty="0">
-                <a:solidFill>
-                  <a:schemeClr val="bg1"/>
-                </a:solidFill>
-                <a:latin typeface="Calibri" panose="020F0502020204030204" pitchFamily="34" charset="0"/>
-                <a:ea typeface="Microsoft YaHei Light" panose="020B0502040204020203" pitchFamily="34" charset="-122"/>
-              </a:rPr>
-              <a:t>Steganografija je tehnika skrivanja poruke unutar drugog digitalnog sadr</a:t>
-            </a:r>
-            <a:r>
-              <a:rPr lang="en-US" altLang="en-US" sz="2000" dirty="0">
-                <a:solidFill>
-                  <a:schemeClr val="bg1"/>
-                </a:solidFill>
-                <a:latin typeface="Calibri" panose="020F0502020204030204" pitchFamily="34" charset="0"/>
-                <a:ea typeface="Microsoft YaHei Light" panose="020B0502040204020203" pitchFamily="34" charset="-122"/>
-              </a:rPr>
-              <a:t>ž</a:t>
-            </a:r>
-            <a:r>
-              <a:rPr lang="en-US" altLang="en-US" sz="2000" dirty="0">
-                <a:solidFill>
-                  <a:schemeClr val="bg1"/>
-                </a:solidFill>
-                <a:latin typeface="Calibri" panose="020F0502020204030204" pitchFamily="34" charset="0"/>
-                <a:ea typeface="Microsoft YaHei Light" panose="020B0502040204020203" pitchFamily="34" charset="-122"/>
-              </a:rPr>
-              <a:t>aja.</a:t>
-            </a:r>
-            <a:endParaRPr lang="en-US" altLang="en-US" sz="2000" dirty="0">
-              <a:solidFill>
-                <a:schemeClr val="bg1"/>
-              </a:solidFill>
-              <a:latin typeface="Calibri" panose="020F0502020204030204" pitchFamily="34" charset="0"/>
-              <a:ea typeface="Microsoft YaHei Light" panose="020B0502040204020203" pitchFamily="34" charset="-122"/>
-            </a:endParaRPr>
-          </a:p>
-          <a:p>
-            <a:pPr marL="342900" indent="-342900" algn="just">
-              <a:buFont typeface="Wingdings" panose="05000000000000000000" charset="0"/>
-              <a:buChar char="v"/>
-            </a:pPr>
-            <a:endParaRPr lang="en-US" altLang="en-US" sz="2000" dirty="0">
-              <a:solidFill>
-                <a:schemeClr val="bg1"/>
-              </a:solidFill>
-              <a:latin typeface="Calibri" panose="020F0502020204030204" pitchFamily="34" charset="0"/>
-              <a:ea typeface="Microsoft YaHei Light" panose="020B0502040204020203" pitchFamily="34" charset="-122"/>
-            </a:endParaRPr>
-          </a:p>
-          <a:p>
-            <a:pPr marL="342900" indent="-342900" algn="just">
-              <a:buFont typeface="Wingdings" panose="05000000000000000000" charset="0"/>
-              <a:buChar char="v"/>
-            </a:pPr>
-            <a:r>
-              <a:rPr lang="en-US" altLang="en-US" sz="2000" dirty="0">
-                <a:solidFill>
-                  <a:schemeClr val="bg1"/>
-                </a:solidFill>
-                <a:latin typeface="Calibri" panose="020F0502020204030204" pitchFamily="34" charset="0"/>
-                <a:ea typeface="Microsoft YaHei Light" panose="020B0502040204020203" pitchFamily="34" charset="-122"/>
-              </a:rPr>
-              <a:t>Cilj nije samo za</a:t>
-            </a:r>
-            <a:r>
-              <a:rPr lang="en-US" altLang="en-US" sz="2000" dirty="0">
-                <a:solidFill>
-                  <a:schemeClr val="bg1"/>
-                </a:solidFill>
-                <a:latin typeface="Calibri" panose="020F0502020204030204" pitchFamily="34" charset="0"/>
-                <a:ea typeface="Microsoft YaHei Light" panose="020B0502040204020203" pitchFamily="34" charset="-122"/>
-              </a:rPr>
-              <a:t>š</a:t>
-            </a:r>
-            <a:r>
-              <a:rPr lang="en-US" altLang="en-US" sz="2000" dirty="0">
-                <a:solidFill>
-                  <a:schemeClr val="bg1"/>
-                </a:solidFill>
-                <a:latin typeface="Calibri" panose="020F0502020204030204" pitchFamily="34" charset="0"/>
-                <a:ea typeface="Microsoft YaHei Light" panose="020B0502040204020203" pitchFamily="34" charset="-122"/>
-              </a:rPr>
-              <a:t>tita sadr</a:t>
-            </a:r>
-            <a:r>
-              <a:rPr lang="en-US" altLang="en-US" sz="2000" dirty="0">
-                <a:solidFill>
-                  <a:schemeClr val="bg1"/>
-                </a:solidFill>
-                <a:latin typeface="Calibri" panose="020F0502020204030204" pitchFamily="34" charset="0"/>
-                <a:ea typeface="Microsoft YaHei Light" panose="020B0502040204020203" pitchFamily="34" charset="-122"/>
-              </a:rPr>
-              <a:t>ž</a:t>
-            </a:r>
-            <a:r>
-              <a:rPr lang="en-US" altLang="en-US" sz="2000" dirty="0">
-                <a:solidFill>
-                  <a:schemeClr val="bg1"/>
-                </a:solidFill>
-                <a:latin typeface="Calibri" panose="020F0502020204030204" pitchFamily="34" charset="0"/>
-                <a:ea typeface="Microsoft YaHei Light" panose="020B0502040204020203" pitchFamily="34" charset="-122"/>
-              </a:rPr>
-              <a:t>aja poruke, ve</a:t>
-            </a:r>
-            <a:r>
-              <a:rPr lang="en-US" altLang="en-US" sz="2000" dirty="0">
-                <a:solidFill>
-                  <a:schemeClr val="bg1"/>
-                </a:solidFill>
-                <a:latin typeface="Calibri" panose="020F0502020204030204" pitchFamily="34" charset="0"/>
-                <a:ea typeface="Microsoft YaHei Light" panose="020B0502040204020203" pitchFamily="34" charset="-122"/>
-              </a:rPr>
-              <a:t>ć </a:t>
-            </a:r>
-            <a:r>
-              <a:rPr lang="en-US" altLang="en-US" sz="2000" dirty="0">
-                <a:solidFill>
-                  <a:schemeClr val="bg1"/>
-                </a:solidFill>
-                <a:latin typeface="Calibri" panose="020F0502020204030204" pitchFamily="34" charset="0"/>
-                <a:ea typeface="Microsoft YaHei Light" panose="020B0502040204020203" pitchFamily="34" charset="-122"/>
-              </a:rPr>
-              <a:t>i skrivanje njenog postojanja.</a:t>
-            </a:r>
-            <a:endParaRPr lang="en-US" altLang="en-US" sz="2000" dirty="0">
-              <a:solidFill>
-                <a:schemeClr val="bg1"/>
-              </a:solidFill>
-              <a:latin typeface="Calibri" panose="020F0502020204030204" pitchFamily="34" charset="0"/>
-              <a:ea typeface="Microsoft YaHei Light" panose="020B0502040204020203" pitchFamily="34" charset="-122"/>
-            </a:endParaRPr>
-          </a:p>
-          <a:p>
-            <a:pPr marL="342900" indent="-342900" algn="just">
-              <a:buFont typeface="Wingdings" panose="05000000000000000000" charset="0"/>
-              <a:buChar char="v"/>
-            </a:pPr>
-            <a:endParaRPr lang="en-US" altLang="en-US" sz="2000" dirty="0">
-              <a:solidFill>
-                <a:schemeClr val="bg1"/>
-              </a:solidFill>
-              <a:latin typeface="Calibri" panose="020F0502020204030204" pitchFamily="34" charset="0"/>
-              <a:ea typeface="Microsoft YaHei Light" panose="020B0502040204020203" pitchFamily="34" charset="-122"/>
-            </a:endParaRPr>
-          </a:p>
-          <a:p>
-            <a:pPr marL="342900" indent="-342900" algn="just">
-              <a:buFont typeface="Wingdings" panose="05000000000000000000" charset="0"/>
-              <a:buChar char="v"/>
-            </a:pPr>
-            <a:r>
-              <a:rPr lang="en-US" altLang="en-US" sz="2000" dirty="0">
-                <a:solidFill>
-                  <a:schemeClr val="bg1"/>
-                </a:solidFill>
-                <a:latin typeface="Calibri" panose="020F0502020204030204" pitchFamily="34" charset="0"/>
-                <a:ea typeface="Microsoft YaHei Light" panose="020B0502040204020203" pitchFamily="34" charset="-122"/>
-              </a:rPr>
-              <a:t>Poruka mo</a:t>
-            </a:r>
-            <a:r>
-              <a:rPr lang="en-US" altLang="en-US" sz="2000" dirty="0">
-                <a:solidFill>
-                  <a:schemeClr val="bg1"/>
-                </a:solidFill>
-                <a:latin typeface="Calibri" panose="020F0502020204030204" pitchFamily="34" charset="0"/>
-                <a:ea typeface="Microsoft YaHei Light" panose="020B0502040204020203" pitchFamily="34" charset="-122"/>
-              </a:rPr>
-              <a:t>ž</a:t>
-            </a:r>
-            <a:r>
-              <a:rPr lang="en-US" altLang="en-US" sz="2000" dirty="0">
-                <a:solidFill>
-                  <a:schemeClr val="bg1"/>
-                </a:solidFill>
-                <a:latin typeface="Calibri" panose="020F0502020204030204" pitchFamily="34" charset="0"/>
-                <a:ea typeface="Microsoft YaHei Light" panose="020B0502040204020203" pitchFamily="34" charset="-122"/>
-              </a:rPr>
-              <a:t>e biti sakrivena u slici, zvuku, videu ili drugom fajlu.</a:t>
-            </a:r>
-            <a:endParaRPr lang="en-US" altLang="en-US" sz="2000" dirty="0">
-              <a:solidFill>
-                <a:schemeClr val="bg1"/>
-              </a:solidFill>
-              <a:latin typeface="Calibri" panose="020F0502020204030204" pitchFamily="34" charset="0"/>
-              <a:ea typeface="Microsoft YaHei Light" panose="020B0502040204020203" pitchFamily="34" charset="-122"/>
-            </a:endParaRPr>
-          </a:p>
-          <a:p>
-            <a:pPr marL="342900" indent="-342900" algn="just">
-              <a:buFont typeface="Wingdings" panose="05000000000000000000" charset="0"/>
-              <a:buChar char="v"/>
-            </a:pPr>
-            <a:endParaRPr lang="en-US" altLang="en-US" sz="2000" dirty="0">
-              <a:solidFill>
-                <a:schemeClr val="bg1"/>
-              </a:solidFill>
-              <a:latin typeface="Calibri" panose="020F0502020204030204" pitchFamily="34" charset="0"/>
-              <a:ea typeface="Microsoft YaHei Light" panose="020B0502040204020203" pitchFamily="34" charset="-122"/>
-            </a:endParaRPr>
-          </a:p>
-          <a:p>
-            <a:pPr marL="342900" indent="-342900" algn="just">
-              <a:buFont typeface="Wingdings" panose="05000000000000000000" charset="0"/>
-              <a:buChar char="v"/>
-            </a:pPr>
-            <a:r>
-              <a:rPr lang="en-US" altLang="en-US" sz="2000" dirty="0">
-                <a:solidFill>
-                  <a:schemeClr val="bg1"/>
-                </a:solidFill>
-                <a:latin typeface="Calibri" panose="020F0502020204030204" pitchFamily="34" charset="0"/>
-                <a:ea typeface="Microsoft YaHei Light" panose="020B0502040204020203" pitchFamily="34" charset="-122"/>
-              </a:rPr>
-              <a:t>Rezultat je stego fajl, koji izgleda isto ili skoro isto kao original.</a:t>
-            </a:r>
-            <a:endParaRPr lang="en-US" altLang="en-US" sz="2000" dirty="0">
-              <a:solidFill>
-                <a:schemeClr val="bg1"/>
-              </a:solidFill>
-              <a:latin typeface="Calibri" panose="020F0502020204030204" pitchFamily="34" charset="0"/>
-              <a:ea typeface="Microsoft YaHei Light" panose="020B0502040204020203" pitchFamily="34" charset="-122"/>
-            </a:endParaRPr>
-          </a:p>
-        </p:txBody>
-      </p:sp>
-      <p:pic>
-        <p:nvPicPr>
-          <p:cNvPr id="9235" name="图片 37" descr="C:/Users/nikol/Downloads/steganography-1.jpgsteganography-1"/>
-          <p:cNvPicPr>
-            <a:picLocks noChangeAspect="1"/>
-          </p:cNvPicPr>
-          <p:nvPr/>
-        </p:nvPicPr>
-        <p:blipFill>
-          <a:blip r:embed="rId1"/>
-          <a:srcRect l="10284" r="10284"/>
-          <a:stretch>
-            <a:fillRect/>
-          </a:stretch>
-        </p:blipFill>
-        <p:spPr>
-          <a:xfrm>
-            <a:off x="840105" y="1808480"/>
-            <a:ext cx="7148195" cy="4655185"/>
-          </a:xfrm>
-          <a:prstGeom prst="rect">
-            <a:avLst/>
-          </a:prstGeom>
-          <a:noFill/>
-          <a:ln w="9525">
-            <a:noFill/>
-          </a:ln>
-        </p:spPr>
-      </p:pic>
-    </p:spTree>
-  </p:cSld>
-  <p:clrMapOvr>
-    <a:masterClrMapping/>
-  </p:clrMapOvr>
-</p:sld>
-</file>
-
-<file path=ppt/slides/slide20.xml><?xml version="1.0" encoding="utf-8"?>
+<file path=ppt/slides/slide22.xml><?xml version="1.0" encoding="utf-8"?>
 <p:sld xmlns:a="http://schemas.openxmlformats.org/drawingml/2006/main" xmlns:r="http://schemas.openxmlformats.org/officeDocument/2006/relationships" xmlns:p="http://schemas.openxmlformats.org/presentationml/2006/main">
   <p:cSld>
     <p:spTree>
@@ -25244,7 +25780,7 @@
 </p:sld>
 </file>
 
-<file path=ppt/slides/slide21.xml><?xml version="1.0" encoding="utf-8"?>
+<file path=ppt/slides/slide23.xml><?xml version="1.0" encoding="utf-8"?>
 <p:sld xmlns:a="http://schemas.openxmlformats.org/drawingml/2006/main" xmlns:r="http://schemas.openxmlformats.org/officeDocument/2006/relationships" xmlns:p="http://schemas.openxmlformats.org/presentationml/2006/main">
   <p:cSld>
     <p:spTree>
@@ -26589,7 +27125,7 @@
 </p:sld>
 </file>
 
-<file path=ppt/slides/slide22.xml><?xml version="1.0" encoding="utf-8"?>
+<file path=ppt/slides/slide24.xml><?xml version="1.0" encoding="utf-8"?>
 <p:sld xmlns:a="http://schemas.openxmlformats.org/drawingml/2006/main" xmlns:r="http://schemas.openxmlformats.org/officeDocument/2006/relationships" xmlns:p="http://schemas.openxmlformats.org/presentationml/2006/main">
   <p:cSld>
     <p:spTree>
@@ -26970,7 +27506,7 @@
 </p:sld>
 </file>
 
-<file path=ppt/slides/slide23.xml><?xml version="1.0" encoding="utf-8"?>
+<file path=ppt/slides/slide25.xml><?xml version="1.0" encoding="utf-8"?>
 <p:sld xmlns:a="http://schemas.openxmlformats.org/drawingml/2006/main" xmlns:r="http://schemas.openxmlformats.org/officeDocument/2006/relationships" xmlns:p="http://schemas.openxmlformats.org/presentationml/2006/main">
   <p:cSld>
     <p:spTree>
@@ -27732,7 +28268,7 @@
 </p:sld>
 </file>
 
-<file path=ppt/slides/slide24.xml><?xml version="1.0" encoding="utf-8"?>
+<file path=ppt/slides/slide26.xml><?xml version="1.0" encoding="utf-8"?>
 <p:sld xmlns:a="http://schemas.openxmlformats.org/drawingml/2006/main" xmlns:r="http://schemas.openxmlformats.org/officeDocument/2006/relationships" xmlns:p="http://schemas.openxmlformats.org/presentationml/2006/main">
   <p:cSld>
     <p:spTree>
@@ -29509,6 +30045,362 @@
       <p:grpSpPr/>
       <p:sp>
         <p:nvSpPr>
+          <p:cNvPr id="2" name="Title 1"/>
+          <p:cNvSpPr>
+            <a:spLocks noGrp="1"/>
+          </p:cNvSpPr>
+          <p:nvPr>
+            <p:ph type="title"/>
+          </p:nvPr>
+        </p:nvSpPr>
+        <p:spPr/>
+        <p:txBody>
+          <a:bodyPr/>
+          <a:p>
+            <a:r>
+              <a:rPr lang="sr-Latn-RS"/>
+              <a:t>Šta je </a:t>
+            </a:r>
+            <a:r>
+              <a:rPr lang="en-US" altLang="sr-Latn-RS"/>
+              <a:t>LSB</a:t>
+            </a:r>
+            <a:r>
+              <a:rPr lang="en-US" altLang="sr-Latn-RS"/>
+              <a:t>  </a:t>
+            </a:r>
+            <a:r>
+              <a:rPr lang="sr-Latn-RS"/>
+              <a:t>(Least Significant Bit)?</a:t>
+            </a:r>
+            <a:endParaRPr lang="sr-Latn-RS"/>
+          </a:p>
+        </p:txBody>
+      </p:sp>
+      <p:sp>
+        <p:nvSpPr>
+          <p:cNvPr id="9" name="矩形 8"/>
+          <p:cNvSpPr/>
+          <p:nvPr/>
+        </p:nvSpPr>
+        <p:spPr>
+          <a:xfrm>
+            <a:off x="8138160" y="3136265"/>
+            <a:ext cx="3894455" cy="3524250"/>
+          </a:xfrm>
+          <a:prstGeom prst="rect">
+            <a:avLst/>
+          </a:prstGeom>
+          <a:solidFill>
+            <a:srgbClr val="1C7C5A"/>
+          </a:solidFill>
+          <a:ln>
+            <a:noFill/>
+          </a:ln>
+        </p:spPr>
+        <p:style>
+          <a:lnRef idx="2">
+            <a:schemeClr val="accent1">
+              <a:shade val="50000"/>
+            </a:schemeClr>
+          </a:lnRef>
+          <a:fillRef idx="1">
+            <a:schemeClr val="accent1"/>
+          </a:fillRef>
+          <a:effectRef idx="0">
+            <a:schemeClr val="accent1"/>
+          </a:effectRef>
+          <a:fontRef idx="minor">
+            <a:schemeClr val="lt1"/>
+          </a:fontRef>
+        </p:style>
+        <p:txBody>
+          <a:bodyPr rtlCol="0" anchor="ctr"/>
+          <a:lstStyle/>
+          <a:p>
+            <a:pPr marL="0" marR="0" lvl="0" indent="0" algn="ctr" defTabSz="914400" rtl="0" eaLnBrk="1" fontAlgn="auto" latinLnBrk="0" hangingPunct="1">
+              <a:lnSpc>
+                <a:spcPct val="100000"/>
+              </a:lnSpc>
+              <a:spcBef>
+                <a:spcPts val="0"/>
+              </a:spcBef>
+              <a:spcAft>
+                <a:spcPts val="0"/>
+              </a:spcAft>
+              <a:buClrTx/>
+              <a:buSzTx/>
+              <a:buFontTx/>
+              <a:buNone/>
+              <a:defRPr/>
+            </a:pPr>
+            <a:endParaRPr kumimoji="0" lang="zh-CN" altLang="en-US" sz="1800" b="0" i="0" u="none" strike="noStrike" kern="1200" cap="none" spc="0" normalizeH="0" baseline="0" noProof="0">
+              <a:ln>
+                <a:noFill/>
+              </a:ln>
+              <a:solidFill>
+                <a:schemeClr val="bg1"/>
+              </a:solidFill>
+              <a:effectLst/>
+              <a:uLnTx/>
+              <a:uFillTx/>
+              <a:latin typeface="+mn-lt"/>
+              <a:ea typeface="+mn-ea"/>
+              <a:cs typeface="+mn-cs"/>
+            </a:endParaRPr>
+          </a:p>
+        </p:txBody>
+      </p:sp>
+      <p:sp>
+        <p:nvSpPr>
+          <p:cNvPr id="3" name="Text Box 2"/>
+          <p:cNvSpPr txBox="1"/>
+          <p:nvPr/>
+        </p:nvSpPr>
+        <p:spPr>
+          <a:xfrm>
+            <a:off x="8138160" y="3136265"/>
+            <a:ext cx="3912235" cy="3415030"/>
+          </a:xfrm>
+          <a:prstGeom prst="rect">
+            <a:avLst/>
+          </a:prstGeom>
+          <a:noFill/>
+        </p:spPr>
+        <p:txBody>
+          <a:bodyPr wrap="square" rtlCol="0">
+            <a:spAutoFit/>
+          </a:bodyPr>
+          <a:p>
+            <a:pPr marL="285750" indent="-285750">
+              <a:buFont typeface="Wingdings" panose="05000000000000000000" charset="0"/>
+              <a:buChar char="v"/>
+            </a:pPr>
+            <a:r>
+              <a:rPr lang="en-US" altLang="en-US">
+                <a:solidFill>
+                  <a:schemeClr val="bg1"/>
+                </a:solidFill>
+              </a:rPr>
+              <a:t>LSB (Least Significant Bit) predstavlja najmanje zna</a:t>
+            </a:r>
+            <a:r>
+              <a:rPr lang="" altLang="en-US">
+                <a:solidFill>
+                  <a:schemeClr val="bg1"/>
+                </a:solidFill>
+              </a:rPr>
+              <a:t>č</a:t>
+            </a:r>
+            <a:r>
+              <a:rPr lang="en-US" altLang="en-US">
+                <a:solidFill>
+                  <a:schemeClr val="bg1"/>
+                </a:solidFill>
+              </a:rPr>
+              <a:t>ajan bit u binarnom zapisu broja, </a:t>
+            </a:r>
+            <a:r>
+              <a:rPr lang="" altLang="en-US">
+                <a:solidFill>
+                  <a:schemeClr val="bg1"/>
+                </a:solidFill>
+              </a:rPr>
+              <a:t>č</a:t>
+            </a:r>
+            <a:r>
+              <a:rPr lang="en-US" altLang="en-US">
+                <a:solidFill>
+                  <a:schemeClr val="bg1"/>
+                </a:solidFill>
+              </a:rPr>
+              <a:t>ija promena najmanje uti</a:t>
+            </a:r>
+            <a:r>
+              <a:rPr lang="" altLang="en-US">
+                <a:solidFill>
+                  <a:schemeClr val="bg1"/>
+                </a:solidFill>
+              </a:rPr>
+              <a:t>č</a:t>
+            </a:r>
+            <a:r>
+              <a:rPr lang="en-US" altLang="en-US">
+                <a:solidFill>
+                  <a:schemeClr val="bg1"/>
+                </a:solidFill>
+              </a:rPr>
+              <a:t>e na ukupnu vrednost podatka.</a:t>
+            </a:r>
+            <a:endParaRPr lang="en-US" altLang="en-US">
+              <a:solidFill>
+                <a:schemeClr val="bg1"/>
+              </a:solidFill>
+            </a:endParaRPr>
+          </a:p>
+          <a:p>
+            <a:pPr marL="285750" indent="-285750">
+              <a:buFont typeface="Wingdings" panose="05000000000000000000" charset="0"/>
+              <a:buChar char="v"/>
+            </a:pPr>
+            <a:endParaRPr lang="en-US" altLang="en-US">
+              <a:solidFill>
+                <a:schemeClr val="bg1"/>
+              </a:solidFill>
+            </a:endParaRPr>
+          </a:p>
+          <a:p>
+            <a:pPr marL="285750" indent="-285750">
+              <a:buFont typeface="Wingdings" panose="05000000000000000000" charset="0"/>
+              <a:buChar char="v"/>
+            </a:pPr>
+            <a:endParaRPr lang="en-US" altLang="en-US">
+              <a:solidFill>
+                <a:schemeClr val="bg1"/>
+              </a:solidFill>
+            </a:endParaRPr>
+          </a:p>
+          <a:p>
+            <a:pPr marL="285750" indent="-285750">
+              <a:buFont typeface="Wingdings" panose="05000000000000000000" charset="0"/>
+              <a:buChar char="v"/>
+            </a:pPr>
+            <a:r>
+              <a:rPr lang="en-US" altLang="en-US">
+                <a:solidFill>
+                  <a:schemeClr val="bg1"/>
+                </a:solidFill>
+                <a:sym typeface="+mn-ea"/>
+              </a:rPr>
+              <a:t>Svaki piksel slike sastoji se od RGB kanala, odnosno crvene, zelene i plave komponente. Svaka od tih komponenti predstavlja se sa 8 bitova.</a:t>
+            </a:r>
+            <a:endParaRPr lang="en-US" altLang="en-US">
+              <a:solidFill>
+                <a:schemeClr val="bg1"/>
+              </a:solidFill>
+            </a:endParaRPr>
+          </a:p>
+          <a:p>
+            <a:pPr marL="285750" indent="-285750">
+              <a:buFont typeface="Wingdings" panose="05000000000000000000" charset="0"/>
+              <a:buChar char="v"/>
+            </a:pPr>
+            <a:endParaRPr lang="en-US" altLang="en-US">
+              <a:solidFill>
+                <a:schemeClr val="bg1"/>
+              </a:solidFill>
+            </a:endParaRPr>
+          </a:p>
+        </p:txBody>
+      </p:sp>
+      <p:pic>
+        <p:nvPicPr>
+          <p:cNvPr id="5" name="Picture 4" descr="lsb"/>
+          <p:cNvPicPr>
+            <a:picLocks noChangeAspect="1"/>
+          </p:cNvPicPr>
+          <p:nvPr/>
+        </p:nvPicPr>
+        <p:blipFill>
+          <a:blip r:embed="rId1"/>
+          <a:stretch>
+            <a:fillRect/>
+          </a:stretch>
+        </p:blipFill>
+        <p:spPr>
+          <a:xfrm>
+            <a:off x="725805" y="1525270"/>
+            <a:ext cx="6407150" cy="2514600"/>
+          </a:xfrm>
+          <a:prstGeom prst="rect">
+            <a:avLst/>
+          </a:prstGeom>
+        </p:spPr>
+      </p:pic>
+      <p:pic>
+        <p:nvPicPr>
+          <p:cNvPr id="6" name="Picture 5" descr="brojac"/>
+          <p:cNvPicPr>
+            <a:picLocks noChangeAspect="1"/>
+          </p:cNvPicPr>
+          <p:nvPr/>
+        </p:nvPicPr>
+        <p:blipFill>
+          <a:blip r:embed="rId2"/>
+          <a:stretch>
+            <a:fillRect/>
+          </a:stretch>
+        </p:blipFill>
+        <p:spPr>
+          <a:xfrm>
+            <a:off x="725805" y="4534535"/>
+            <a:ext cx="6406515" cy="2016760"/>
+          </a:xfrm>
+          <a:prstGeom prst="rect">
+            <a:avLst/>
+          </a:prstGeom>
+        </p:spPr>
+      </p:pic>
+    </p:spTree>
+  </p:cSld>
+  <p:clrMapOvr>
+    <a:masterClrMapping/>
+  </p:clrMapOvr>
+</p:sld>
+</file>
+
+<file path=ppt/slides/slide6.xml><?xml version="1.0" encoding="utf-8"?>
+<p:sld xmlns:a="http://schemas.openxmlformats.org/drawingml/2006/main" xmlns:r="http://schemas.openxmlformats.org/officeDocument/2006/relationships" xmlns:p="http://schemas.openxmlformats.org/presentationml/2006/main">
+  <p:cSld>
+    <p:spTree>
+      <p:nvGrpSpPr>
+        <p:cNvPr id="1" name=""/>
+        <p:cNvGrpSpPr/>
+        <p:nvPr/>
+      </p:nvGrpSpPr>
+      <p:grpSpPr/>
+      <p:sp>
+        <p:nvSpPr>
+          <p:cNvPr id="2" name="Title 1"/>
+          <p:cNvSpPr>
+            <a:spLocks noGrp="1"/>
+          </p:cNvSpPr>
+          <p:nvPr>
+            <p:ph type="title"/>
+          </p:nvPr>
+        </p:nvSpPr>
+        <p:spPr/>
+        <p:txBody>
+          <a:bodyPr/>
+          <a:p>
+            <a:r>
+              <a:rPr lang="en-US"/>
+              <a:t>Kako se poruka pretvara u bitove?</a:t>
+            </a:r>
+            <a:endParaRPr lang="en-US"/>
+          </a:p>
+        </p:txBody>
+      </p:sp>
+    </p:spTree>
+  </p:cSld>
+  <p:clrMapOvr>
+    <a:masterClrMapping/>
+  </p:clrMapOvr>
+</p:sld>
+</file>
+
+<file path=ppt/slides/slide7.xml><?xml version="1.0" encoding="utf-8"?>
+<p:sld xmlns:a="http://schemas.openxmlformats.org/drawingml/2006/main" xmlns:r="http://schemas.openxmlformats.org/officeDocument/2006/relationships" xmlns:p="http://schemas.openxmlformats.org/presentationml/2006/main">
+  <p:cSld>
+    <p:spTree>
+      <p:nvGrpSpPr>
+        <p:cNvPr id="1" name=""/>
+        <p:cNvGrpSpPr/>
+        <p:nvPr/>
+      </p:nvGrpSpPr>
+      <p:grpSpPr/>
+      <p:sp>
+        <p:nvSpPr>
           <p:cNvPr id="8" name="Rectangle 7"/>
           <p:cNvSpPr/>
           <p:nvPr/>
@@ -29568,7 +30460,7 @@
               <a:t>Za</a:t>
             </a:r>
             <a:r>
-              <a:rPr lang="" altLang="en-US"/>
+              <a:rPr lang="en-US" altLang="en-US"/>
               <a:t>š</a:t>
             </a:r>
             <a:r>
@@ -29933,7 +30825,7 @@
               <a:t>Podaci se ne kriju u pikselima, ve</a:t>
             </a:r>
             <a:r>
-              <a:rPr lang="" altLang="en-US">
+              <a:rPr lang="en-US" altLang="en-US">
                 <a:solidFill>
                   <a:schemeClr val="bg1"/>
                 </a:solidFill>
@@ -29949,7 +30841,7 @@
               <a:t>u matemati</a:t>
             </a:r>
             <a:r>
-              <a:rPr lang="" altLang="en-US">
+              <a:rPr lang="en-US" altLang="en-US">
                 <a:solidFill>
                   <a:schemeClr val="bg1"/>
                 </a:solidFill>
@@ -30000,7 +30892,7 @@
               <a:t> Vizuelni napadi su nemogu</a:t>
             </a:r>
             <a:r>
-              <a:rPr lang="" altLang="en-US">
+              <a:rPr lang="en-US" altLang="en-US">
                 <a:solidFill>
                   <a:schemeClr val="bg1"/>
                 </a:solidFill>
@@ -30016,7 +30908,7 @@
               <a:t>i. Izmene se tokom prikaza prirodno "razma</a:t>
             </a:r>
             <a:r>
-              <a:rPr lang="" altLang="en-US">
+              <a:rPr lang="en-US" altLang="en-US">
                 <a:solidFill>
                   <a:schemeClr val="bg1"/>
                 </a:solidFill>
@@ -30063,7 +30955,7 @@
 </p:sld>
 </file>
 
-<file path=ppt/slides/slide6.xml><?xml version="1.0" encoding="utf-8"?>
+<file path=ppt/slides/slide8.xml><?xml version="1.0" encoding="utf-8"?>
 <p:sld xmlns:a="http://schemas.openxmlformats.org/drawingml/2006/main" xmlns:r="http://schemas.openxmlformats.org/officeDocument/2006/relationships" xmlns:p="http://schemas.openxmlformats.org/presentationml/2006/main">
   <p:cSld>
     <p:spTree>
@@ -30452,7 +31344,7 @@
 </p:sld>
 </file>
 
-<file path=ppt/slides/slide7.xml><?xml version="1.0" encoding="utf-8"?>
+<file path=ppt/slides/slide9.xml><?xml version="1.0" encoding="utf-8"?>
 <p:sld xmlns:a="http://schemas.openxmlformats.org/drawingml/2006/main" xmlns:r="http://schemas.openxmlformats.org/officeDocument/2006/relationships" xmlns:p="http://schemas.openxmlformats.org/presentationml/2006/main">
   <p:cSld>
     <p:spTree>
@@ -30688,540 +31580,6 @@
               <a:t>Statistički Hi-kvadrat test</a:t>
             </a:r>
             <a:endParaRPr lang="sr-Latn-RS" altLang="en-US" sz="2000">
-              <a:solidFill>
-                <a:schemeClr val="bg1"/>
-              </a:solidFill>
-            </a:endParaRPr>
-          </a:p>
-        </p:txBody>
-      </p:sp>
-    </p:spTree>
-  </p:cSld>
-  <p:clrMapOvr>
-    <a:masterClrMapping/>
-  </p:clrMapOvr>
-</p:sld>
-</file>
-
-<file path=ppt/slides/slide8.xml><?xml version="1.0" encoding="utf-8"?>
-<p:sld xmlns:a="http://schemas.openxmlformats.org/drawingml/2006/main" xmlns:r="http://schemas.openxmlformats.org/officeDocument/2006/relationships" xmlns:p="http://schemas.openxmlformats.org/presentationml/2006/main">
-  <p:cSld>
-    <p:spTree>
-      <p:nvGrpSpPr>
-        <p:cNvPr id="1" name=""/>
-        <p:cNvGrpSpPr/>
-        <p:nvPr/>
-      </p:nvGrpSpPr>
-      <p:grpSpPr/>
-      <p:sp>
-        <p:nvSpPr>
-          <p:cNvPr id="2" name="Title 1"/>
-          <p:cNvSpPr>
-            <a:spLocks noGrp="1"/>
-          </p:cNvSpPr>
-          <p:nvPr>
-            <p:ph type="title"/>
-          </p:nvPr>
-        </p:nvSpPr>
-        <p:spPr/>
-        <p:txBody>
-          <a:bodyPr/>
-          <a:p>
-            <a:pPr algn="ctr"/>
-            <a:r>
-              <a:rPr lang="en-US" altLang="en-US"/>
-              <a:t>OutGuess (v0.1)</a:t>
-            </a:r>
-            <a:endParaRPr lang="en-US" altLang="en-US"/>
-          </a:p>
-        </p:txBody>
-      </p:sp>
-      <p:sp>
-        <p:nvSpPr>
-          <p:cNvPr id="3" name="Text Box 2"/>
-          <p:cNvSpPr txBox="1"/>
-          <p:nvPr/>
-        </p:nvSpPr>
-        <p:spPr>
-          <a:xfrm>
-            <a:off x="2176145" y="2428240"/>
-            <a:ext cx="7840345" cy="2553335"/>
-          </a:xfrm>
-          <a:prstGeom prst="rect">
-            <a:avLst/>
-          </a:prstGeom>
-          <a:noFill/>
-        </p:spPr>
-        <p:txBody>
-          <a:bodyPr wrap="square" rtlCol="0">
-            <a:spAutoFit/>
-          </a:bodyPr>
-          <a:p>
-            <a:pPr marL="285750" indent="-285750">
-              <a:buFont typeface="Wingdings" panose="05000000000000000000" charset="0"/>
-              <a:buChar char="v"/>
-            </a:pPr>
-            <a:r>
-              <a:rPr lang="en-US" altLang="en-US" sz="2000" b="1">
-                <a:solidFill>
-                  <a:schemeClr val="bg1"/>
-                </a:solidFill>
-              </a:rPr>
-              <a:t>Ideja</a:t>
-            </a:r>
-            <a:endParaRPr lang="en-US" altLang="en-US" sz="2000">
-              <a:solidFill>
-                <a:schemeClr val="bg1"/>
-              </a:solidFill>
-            </a:endParaRPr>
-          </a:p>
-          <a:p>
-            <a:pPr marL="285750" indent="-285750">
-              <a:buFont typeface="Wingdings" panose="05000000000000000000" charset="0"/>
-              <a:buChar char="v"/>
-            </a:pPr>
-            <a:endParaRPr lang="en-US" altLang="en-US" sz="2000">
-              <a:solidFill>
-                <a:schemeClr val="bg1"/>
-              </a:solidFill>
-            </a:endParaRPr>
-          </a:p>
-          <a:p>
-            <a:pPr marL="285750" indent="-285750">
-              <a:buFont typeface="Wingdings" panose="05000000000000000000" charset="0"/>
-              <a:buChar char="v"/>
-            </a:pPr>
-            <a:r>
-              <a:rPr lang="en-US" altLang="en-US" sz="2000" b="1">
-                <a:solidFill>
-                  <a:schemeClr val="bg1"/>
-                </a:solidFill>
-              </a:rPr>
-              <a:t>Za</a:t>
-            </a:r>
-            <a:r>
-              <a:rPr lang="" altLang="en-US" sz="2000" b="1">
-                <a:solidFill>
-                  <a:schemeClr val="bg1"/>
-                </a:solidFill>
-              </a:rPr>
-              <a:t>š</a:t>
-            </a:r>
-            <a:r>
-              <a:rPr lang="en-US" altLang="en-US" sz="2000" b="1">
-                <a:solidFill>
-                  <a:schemeClr val="bg1"/>
-                </a:solidFill>
-              </a:rPr>
-              <a:t>to je bolji od obi</a:t>
-            </a:r>
-            <a:r>
-              <a:rPr lang="" altLang="en-US" sz="2000" b="1">
-                <a:solidFill>
-                  <a:schemeClr val="bg1"/>
-                </a:solidFill>
-              </a:rPr>
-              <a:t>č</a:t>
-            </a:r>
-            <a:r>
-              <a:rPr lang="en-US" altLang="en-US" sz="2000" b="1">
-                <a:solidFill>
-                  <a:schemeClr val="bg1"/>
-                </a:solidFill>
-              </a:rPr>
-              <a:t>nog LSB-a? </a:t>
-            </a:r>
-            <a:endParaRPr lang="en-US" altLang="en-US" sz="2000" b="1">
-              <a:solidFill>
-                <a:schemeClr val="bg1"/>
-              </a:solidFill>
-            </a:endParaRPr>
-          </a:p>
-          <a:p>
-            <a:pPr marL="285750" indent="-285750">
-              <a:buFont typeface="Wingdings" panose="05000000000000000000" charset="0"/>
-              <a:buChar char="v"/>
-            </a:pPr>
-            <a:endParaRPr lang="en-US" altLang="en-US" sz="2000">
-              <a:solidFill>
-                <a:schemeClr val="bg1"/>
-              </a:solidFill>
-            </a:endParaRPr>
-          </a:p>
-          <a:p>
-            <a:pPr marL="285750" indent="-285750">
-              <a:buFont typeface="Wingdings" panose="05000000000000000000" charset="0"/>
-              <a:buChar char="v"/>
-            </a:pPr>
-            <a:r>
-              <a:rPr lang="en-US" altLang="en-US" sz="2000" b="1">
-                <a:solidFill>
-                  <a:schemeClr val="bg1"/>
-                </a:solidFill>
-              </a:rPr>
-              <a:t>Rezultat: Globalni Hi-kvadrat test sa po</a:t>
-            </a:r>
-            <a:r>
-              <a:rPr lang="" altLang="en-US" sz="2000" b="1">
-                <a:solidFill>
-                  <a:schemeClr val="bg1"/>
-                </a:solidFill>
-              </a:rPr>
-              <a:t>č</a:t>
-            </a:r>
-            <a:r>
-              <a:rPr lang="en-US" altLang="en-US" sz="2000" b="1">
-                <a:solidFill>
-                  <a:schemeClr val="bg1"/>
-                </a:solidFill>
-              </a:rPr>
-              <a:t>etka slike vi</a:t>
-            </a:r>
-            <a:r>
-              <a:rPr lang="" altLang="en-US" sz="2000" b="1">
-                <a:solidFill>
-                  <a:schemeClr val="bg1"/>
-                </a:solidFill>
-              </a:rPr>
-              <a:t>š</a:t>
-            </a:r>
-            <a:r>
-              <a:rPr lang="en-US" altLang="en-US" sz="2000" b="1">
-                <a:solidFill>
-                  <a:schemeClr val="bg1"/>
-                </a:solidFill>
-              </a:rPr>
-              <a:t>e ne vidi anomaliju jer je </a:t>
-            </a:r>
-            <a:r>
-              <a:rPr lang="" altLang="en-US" sz="2000" b="1">
-                <a:solidFill>
-                  <a:schemeClr val="bg1"/>
-                </a:solidFill>
-              </a:rPr>
-              <a:t>š</a:t>
-            </a:r>
-            <a:r>
-              <a:rPr lang="en-US" altLang="en-US" sz="2000" b="1">
-                <a:solidFill>
-                  <a:schemeClr val="bg1"/>
-                </a:solidFill>
-              </a:rPr>
-              <a:t>um previ</a:t>
-            </a:r>
-            <a:r>
-              <a:rPr lang="" altLang="en-US" sz="2000" b="1">
-                <a:solidFill>
-                  <a:schemeClr val="bg1"/>
-                </a:solidFill>
-              </a:rPr>
-              <a:t>š</a:t>
-            </a:r>
-            <a:r>
-              <a:rPr lang="en-US" altLang="en-US" sz="2000" b="1">
-                <a:solidFill>
-                  <a:schemeClr val="bg1"/>
-                </a:solidFill>
-              </a:rPr>
-              <a:t>e razvu</a:t>
-            </a:r>
-            <a:r>
-              <a:rPr lang="" altLang="en-US" sz="2000" b="1">
-                <a:solidFill>
-                  <a:schemeClr val="bg1"/>
-                </a:solidFill>
-              </a:rPr>
-              <a:t>č</a:t>
-            </a:r>
-            <a:r>
-              <a:rPr lang="en-US" altLang="en-US" sz="2000" b="1">
-                <a:solidFill>
-                  <a:schemeClr val="bg1"/>
-                </a:solidFill>
-              </a:rPr>
-              <a:t>en.</a:t>
-            </a:r>
-            <a:endParaRPr lang="en-US" altLang="en-US" sz="2000" b="1">
-              <a:solidFill>
-                <a:schemeClr val="bg1"/>
-              </a:solidFill>
-            </a:endParaRPr>
-          </a:p>
-          <a:p>
-            <a:pPr marL="285750" indent="-285750">
-              <a:buFont typeface="Wingdings" panose="05000000000000000000" charset="0"/>
-              <a:buChar char="v"/>
-            </a:pPr>
-            <a:endParaRPr lang="en-US" altLang="en-US" sz="2000">
-              <a:solidFill>
-                <a:schemeClr val="bg1"/>
-              </a:solidFill>
-            </a:endParaRPr>
-          </a:p>
-          <a:p>
-            <a:pPr marL="285750" indent="-285750">
-              <a:buFont typeface="Wingdings" panose="05000000000000000000" charset="0"/>
-              <a:buChar char="v"/>
-            </a:pPr>
-            <a:r>
-              <a:rPr lang="en-US" altLang="en-US" sz="2000" b="1">
-                <a:solidFill>
-                  <a:schemeClr val="bg1"/>
-                </a:solidFill>
-              </a:rPr>
-              <a:t>Kako ipak pada? </a:t>
-            </a:r>
-            <a:r>
-              <a:rPr lang="sr-Latn-RS" altLang="en-US" sz="2000" b="1">
-                <a:solidFill>
-                  <a:schemeClr val="bg1"/>
-                </a:solidFill>
-              </a:rPr>
-              <a:t>(Sliding window)</a:t>
-            </a:r>
-            <a:endParaRPr lang="sr-Latn-RS" altLang="en-US" sz="2000" b="1">
-              <a:solidFill>
-                <a:schemeClr val="bg1"/>
-              </a:solidFill>
-            </a:endParaRPr>
-          </a:p>
-        </p:txBody>
-      </p:sp>
-    </p:spTree>
-  </p:cSld>
-  <p:clrMapOvr>
-    <a:masterClrMapping/>
-  </p:clrMapOvr>
-</p:sld>
-</file>
-
-<file path=ppt/slides/slide9.xml><?xml version="1.0" encoding="utf-8"?>
-<p:sld xmlns:a="http://schemas.openxmlformats.org/drawingml/2006/main" xmlns:r="http://schemas.openxmlformats.org/officeDocument/2006/relationships" xmlns:p="http://schemas.openxmlformats.org/presentationml/2006/main">
-  <p:cSld>
-    <p:spTree>
-      <p:nvGrpSpPr>
-        <p:cNvPr id="1" name=""/>
-        <p:cNvGrpSpPr/>
-        <p:nvPr/>
-      </p:nvGrpSpPr>
-      <p:grpSpPr/>
-      <p:sp>
-        <p:nvSpPr>
-          <p:cNvPr id="2" name="Title 1"/>
-          <p:cNvSpPr>
-            <a:spLocks noGrp="1"/>
-          </p:cNvSpPr>
-          <p:nvPr>
-            <p:ph type="title"/>
-          </p:nvPr>
-        </p:nvSpPr>
-        <p:spPr/>
-        <p:txBody>
-          <a:bodyPr/>
-          <a:p>
-            <a:pPr algn="ctr"/>
-            <a:r>
-              <a:rPr lang="en-US" altLang="en-US"/>
-              <a:t>OutGuess 0.2 i F5</a:t>
-            </a:r>
-            <a:endParaRPr lang="en-US" altLang="en-US"/>
-          </a:p>
-        </p:txBody>
-      </p:sp>
-      <p:sp>
-        <p:nvSpPr>
-          <p:cNvPr id="3" name="Text Box 2"/>
-          <p:cNvSpPr txBox="1"/>
-          <p:nvPr/>
-        </p:nvSpPr>
-        <p:spPr>
-          <a:xfrm>
-            <a:off x="2494280" y="2251075"/>
-            <a:ext cx="7204075" cy="2861310"/>
-          </a:xfrm>
-          <a:prstGeom prst="rect">
-            <a:avLst/>
-          </a:prstGeom>
-          <a:noFill/>
-        </p:spPr>
-        <p:txBody>
-          <a:bodyPr wrap="square" rtlCol="0">
-            <a:spAutoFit/>
-          </a:bodyPr>
-          <a:p>
-            <a:pPr marL="285750" indent="-285750">
-              <a:buFont typeface="Wingdings" panose="05000000000000000000" charset="0"/>
-              <a:buChar char="v"/>
-            </a:pPr>
-            <a:r>
-              <a:rPr lang="en-US" altLang="en-US" sz="2000" b="1">
-                <a:solidFill>
-                  <a:schemeClr val="bg1"/>
-                </a:solidFill>
-              </a:rPr>
-              <a:t>OutGuess 0.2 – Korektivne transformacije:</a:t>
-            </a:r>
-            <a:endParaRPr lang="en-US" altLang="en-US" sz="2000" b="1">
-              <a:solidFill>
-                <a:schemeClr val="bg1"/>
-              </a:solidFill>
-            </a:endParaRPr>
-          </a:p>
-          <a:p>
-            <a:pPr marL="285750" indent="-285750">
-              <a:buFont typeface="Wingdings" panose="05000000000000000000" charset="0"/>
-              <a:buChar char="v"/>
-            </a:pPr>
-            <a:endParaRPr lang="en-US" altLang="en-US" sz="2000" b="1">
-              <a:solidFill>
-                <a:schemeClr val="bg1"/>
-              </a:solidFill>
-            </a:endParaRPr>
-          </a:p>
-          <a:p>
-            <a:pPr marL="742950" lvl="1" indent="-285750">
-              <a:buFont typeface="Wingdings" panose="05000000000000000000" charset="0"/>
-              <a:buChar char="v"/>
-            </a:pPr>
-            <a:r>
-              <a:rPr lang="en-US" altLang="en-US" sz="2000" b="1">
-                <a:solidFill>
-                  <a:schemeClr val="bg1"/>
-                </a:solidFill>
-              </a:rPr>
-              <a:t>Ideja</a:t>
-            </a:r>
-            <a:r>
-              <a:rPr lang="sr-Latn-RS" altLang="en-US" sz="2000" b="1">
-                <a:solidFill>
-                  <a:schemeClr val="bg1"/>
-                </a:solidFill>
-              </a:rPr>
-              <a:t> (Veštačka popravka histograma)</a:t>
-            </a:r>
-            <a:endParaRPr lang="en-US" altLang="en-US" sz="2000" b="1">
-              <a:solidFill>
-                <a:schemeClr val="bg1"/>
-              </a:solidFill>
-            </a:endParaRPr>
-          </a:p>
-          <a:p>
-            <a:pPr marL="285750" indent="-285750">
-              <a:buFont typeface="Wingdings" panose="05000000000000000000" charset="0"/>
-              <a:buChar char="v"/>
-            </a:pPr>
-            <a:endParaRPr lang="en-US" altLang="en-US" sz="2000" b="1">
-              <a:solidFill>
-                <a:schemeClr val="bg1"/>
-              </a:solidFill>
-            </a:endParaRPr>
-          </a:p>
-          <a:p>
-            <a:pPr marL="285750" indent="-285750">
-              <a:buFont typeface="Wingdings" panose="05000000000000000000" charset="0"/>
-              <a:buChar char="v"/>
-            </a:pPr>
-            <a:r>
-              <a:rPr lang="en-US" altLang="en-US" sz="2000" b="1">
-                <a:solidFill>
-                  <a:schemeClr val="bg1"/>
-                </a:solidFill>
-              </a:rPr>
-              <a:t>F5 – Matri</a:t>
-            </a:r>
-            <a:r>
-              <a:rPr lang="" altLang="en-US" sz="2000" b="1">
-                <a:solidFill>
-                  <a:schemeClr val="bg1"/>
-                </a:solidFill>
-              </a:rPr>
-              <a:t>č</a:t>
-            </a:r>
-            <a:r>
-              <a:rPr lang="en-US" altLang="en-US" sz="2000" b="1">
-                <a:solidFill>
-                  <a:schemeClr val="bg1"/>
-                </a:solidFill>
-              </a:rPr>
-              <a:t>no kodiranje (Hammingov kod):</a:t>
-            </a:r>
-            <a:endParaRPr lang="en-US" altLang="en-US" sz="2000" b="1">
-              <a:solidFill>
-                <a:schemeClr val="bg1"/>
-              </a:solidFill>
-            </a:endParaRPr>
-          </a:p>
-          <a:p>
-            <a:pPr marL="285750" indent="-285750">
-              <a:buFont typeface="Wingdings" panose="05000000000000000000" charset="0"/>
-              <a:buChar char="v"/>
-            </a:pPr>
-            <a:endParaRPr lang="en-US" altLang="en-US" sz="2000" b="1">
-              <a:solidFill>
-                <a:schemeClr val="bg1"/>
-              </a:solidFill>
-            </a:endParaRPr>
-          </a:p>
-          <a:p>
-            <a:pPr marL="742950" lvl="1" indent="-285750">
-              <a:buFont typeface="Wingdings" panose="05000000000000000000" charset="0"/>
-              <a:buChar char="v"/>
-            </a:pPr>
-            <a:r>
-              <a:rPr lang="en-US" altLang="en-US" sz="2000" b="1">
-                <a:solidFill>
-                  <a:schemeClr val="bg1"/>
-                </a:solidFill>
-              </a:rPr>
-              <a:t>Ideja: </a:t>
-            </a:r>
-            <a:r>
-              <a:rPr lang="sr-Latn-RS" altLang="en-US" sz="2000" b="1">
-                <a:solidFill>
-                  <a:schemeClr val="bg1"/>
-                </a:solidFill>
-              </a:rPr>
-              <a:t>Oduzimanje bitova</a:t>
-            </a:r>
-            <a:endParaRPr lang="en-US" altLang="en-US" sz="2000" b="1">
-              <a:solidFill>
-                <a:schemeClr val="bg1"/>
-              </a:solidFill>
-            </a:endParaRPr>
-          </a:p>
-          <a:p>
-            <a:pPr marL="285750" indent="-285750">
-              <a:buFont typeface="Wingdings" panose="05000000000000000000" charset="0"/>
-              <a:buChar char="v"/>
-            </a:pPr>
-            <a:endParaRPr lang="en-US" altLang="en-US" sz="2000" b="1">
-              <a:solidFill>
-                <a:schemeClr val="bg1"/>
-              </a:solidFill>
-            </a:endParaRPr>
-          </a:p>
-          <a:p>
-            <a:pPr marL="742950" lvl="1" indent="-285750">
-              <a:buFont typeface="Wingdings" panose="05000000000000000000" charset="0"/>
-              <a:buChar char="v"/>
-            </a:pPr>
-            <a:r>
-              <a:rPr lang="en-US" altLang="en-US" sz="2000" b="1">
-                <a:solidFill>
-                  <a:schemeClr val="bg1"/>
-                </a:solidFill>
-              </a:rPr>
-              <a:t>Efekat: </a:t>
-            </a:r>
-            <a:r>
-              <a:rPr lang="sr-Latn-RS" altLang="en-US" sz="2000" b="1">
-                <a:solidFill>
-                  <a:schemeClr val="bg1"/>
-                </a:solidFill>
-              </a:rPr>
-              <a:t>Upis veće količine podataka sa manjim izmenama</a:t>
-            </a:r>
-            <a:endParaRPr lang="sr-Latn-RS" altLang="en-US" sz="2000" b="1">
               <a:solidFill>
                 <a:schemeClr val="bg1"/>
               </a:solidFill>

</xml_diff>